<commit_message>
Update SKY presentation with gameplay comparison
</commit_message>
<xml_diff>
--- a/public/presentations/Blue_Rescue_SKY_Olimpiyatlari_Sunumu.pptx
+++ b/public/presentations/Blue_Rescue_SKY_Olimpiyatlari_Sunumu.pptx
@@ -2,19 +2,19 @@
 <file path=ppt/presentation.xml><?xml version="1.0" encoding="utf-8"?>
 <p:presentation xmlns:p="http://schemas.openxmlformats.org/presentationml/2006/main">
   <p:sldMasterIdLst>
-    <p:sldMasterId xmlns:r="http://schemas.openxmlformats.org/officeDocument/2006/relationships" id="2147483648" r:id="R449e69b94bed4c36"/>
+    <p:sldMasterId xmlns:r="http://schemas.openxmlformats.org/officeDocument/2006/relationships" id="2147483648" r:id="R7e97a7ba80474af5"/>
   </p:sldMasterIdLst>
   <p:notesMasterIdLst>
-    <p:notesMasterId xmlns:r="http://schemas.openxmlformats.org/officeDocument/2006/relationships" r:id="Rb48af3723adc416a"/>
+    <p:notesMasterId xmlns:r="http://schemas.openxmlformats.org/officeDocument/2006/relationships" r:id="R4971e5f5eb2e49d5"/>
   </p:notesMasterIdLst>
   <p:sldIdLst>
-    <p:sldId xmlns:r="http://schemas.openxmlformats.org/officeDocument/2006/relationships" id="256" r:id="R5c7e00a5b56145bc"/>
-    <p:sldId xmlns:r="http://schemas.openxmlformats.org/officeDocument/2006/relationships" id="257" r:id="R2e31eba298cc4310"/>
-    <p:sldId xmlns:r="http://schemas.openxmlformats.org/officeDocument/2006/relationships" id="258" r:id="Re1a0b9abbcb344e7"/>
-    <p:sldId xmlns:r="http://schemas.openxmlformats.org/officeDocument/2006/relationships" id="259" r:id="R94ae2739a0764a3d"/>
-    <p:sldId xmlns:r="http://schemas.openxmlformats.org/officeDocument/2006/relationships" id="260" r:id="Rfc00a664585b4925"/>
-    <p:sldId xmlns:r="http://schemas.openxmlformats.org/officeDocument/2006/relationships" id="261" r:id="R3b9648df4954456c"/>
-    <p:sldId xmlns:r="http://schemas.openxmlformats.org/officeDocument/2006/relationships" id="262" r:id="R6df22aecef3c4408"/>
+    <p:sldId xmlns:r="http://schemas.openxmlformats.org/officeDocument/2006/relationships" id="256" r:id="R5fbe878f4fc5448d"/>
+    <p:sldId xmlns:r="http://schemas.openxmlformats.org/officeDocument/2006/relationships" id="257" r:id="Rf45362f78b174807"/>
+    <p:sldId xmlns:r="http://schemas.openxmlformats.org/officeDocument/2006/relationships" id="258" r:id="R6818673fe5d54ff7"/>
+    <p:sldId xmlns:r="http://schemas.openxmlformats.org/officeDocument/2006/relationships" id="259" r:id="Rc1dec57feb674946"/>
+    <p:sldId xmlns:r="http://schemas.openxmlformats.org/officeDocument/2006/relationships" id="260" r:id="R2755b233417f471a"/>
+    <p:sldId xmlns:r="http://schemas.openxmlformats.org/officeDocument/2006/relationships" id="261" r:id="Re9edd172c70044b5"/>
+    <p:sldId xmlns:r="http://schemas.openxmlformats.org/officeDocument/2006/relationships" id="262" r:id="R31104ebeac00438c"/>
   </p:sldIdLst>
   <p:sldSz cx="12192000" cy="6858000"/>
   <p:notesSz cx="6858000" cy="9144000"/>
@@ -448,21 +448,6 @@
           <a:lstStyle xmlns:a="http://schemas.openxmlformats.org/drawingml/2006/main"/>
           <a:p xmlns:a="http://schemas.openxmlformats.org/drawingml/2006/main">
             <a:r>
-              <a:t>Bu projeyi SKY Olimpiyatları için hazırladım.</a:t>
-            </a:r>
-          </a:p>
-          <a:p xmlns:a="http://schemas.openxmlformats.org/drawingml/2006/main">
-            <a:r>
-              <a:t>GÖKBEY Isıl ve Akışkanlar Analizi tarafında staj yapıyorum. Beklenen seçenek, yaptığım teknik bir analizi anlatmaktı. Ben biraz daha beklenmedik ve akılda kalıcı bir şey yapmak istedim.</a:t>
-            </a:r>
-          </a:p>
-          <a:p xmlns:a="http://schemas.openxmlformats.org/drawingml/2006/main">
-            <a:r>
-              <a:t/>
-            </a:r>
-          </a:p>
-          <a:p xmlns:a="http://schemas.openxmlformats.org/drawingml/2006/main">
-            <a:r>
               <a:t>[Sources]</a:t>
             </a:r>
           </a:p>
@@ -543,27 +528,17 @@
           <a:lstStyle xmlns:a="http://schemas.openxmlformats.org/drawingml/2006/main"/>
           <a:p xmlns:a="http://schemas.openxmlformats.org/drawingml/2006/main">
             <a:r>
-              <a:t>Stajımın doğal devamı olarak bir ısıl analiz örneği sunabilirdim. Bu yanlış olmazdı; sadece beklenen olurdu.</a:t>
-            </a:r>
-          </a:p>
-          <a:p xmlns:a="http://schemas.openxmlformats.org/drawingml/2006/main">
-            <a:r>
-              <a:t>SKY Olimpiyatları için izleyicinin doğrudan deneyebileceği, küçük ama tamamlanmış bir iş göstermenin daha güçlü olacağını düşündüm.</a:t>
-            </a:r>
-          </a:p>
-          <a:p xmlns:a="http://schemas.openxmlformats.org/drawingml/2006/main">
-            <a:r>
-              <a:t/>
-            </a:r>
-          </a:p>
-          <a:p xmlns:a="http://schemas.openxmlformats.org/drawingml/2006/main">
-            <a:r>
               <a:t>[Sources]</a:t>
             </a:r>
           </a:p>
           <a:p xmlns:a="http://schemas.openxmlformats.org/drawingml/2006/main">
             <a:r>
-              <a:t>Karar süreci: kullanıcı tarafından sağlanan kişisel proje bağlamı.</a:t>
+              <a:t>OECD yetkinlik görevi: D:/tusasgame/.codex-remote-attachments/01a063e3-e8fc-7582-98a8-5398743959a2/ca5e8630-ec9d-4974-a47c-6d3ca6b16fcb/1-Photo-1.jpg</a:t>
+            </a:r>
+          </a:p>
+          <a:p xmlns:a="http://schemas.openxmlformats.org/drawingml/2006/main">
+            <a:r>
+              <a:t>Yetkinlik eşlemesi: Yaratıcılık ve İnovasyon; destekleyici olarak Problem Çözme ve Dijital Okuryazarlık.</a:t>
             </a:r>
           </a:p>
         </p:txBody>
@@ -633,27 +608,12 @@
           <a:lstStyle xmlns:a="http://schemas.openxmlformats.org/drawingml/2006/main"/>
           <a:p xmlns:a="http://schemas.openxmlformats.org/drawingml/2006/main">
             <a:r>
-              <a:t>Burada özellikle büyük bir anlam üretmeye gerek yok: GÖKBEY tarafında olduğum için helikopter teması bana doğal geldi.</a:t>
-            </a:r>
-          </a:p>
-          <a:p xmlns:a="http://schemas.openxmlformats.org/drawingml/2006/main">
-            <a:r>
-              <a:t>Oyundaki araç tamamen generic bir mavi kurtarma helikopteri. Resmî logo ya da ürün görseli kullanmadım.</a:t>
-            </a:r>
-          </a:p>
-          <a:p xmlns:a="http://schemas.openxmlformats.org/drawingml/2006/main">
-            <a:r>
-              <a:t/>
-            </a:r>
-          </a:p>
-          <a:p xmlns:a="http://schemas.openxmlformats.org/drawingml/2006/main">
-            <a:r>
               <a:t>[Sources]</a:t>
             </a:r>
           </a:p>
           <a:p xmlns:a="http://schemas.openxmlformats.org/drawingml/2006/main">
             <a:r>
-              <a:t>Staj bağlamı: kullanıcı tarafından sağlanan bilgiler.</a:t>
+              <a:t>GÖKBEY stajı ve prototip projesi deneyimi: kullanıcı tarafından sağlanan kişisel bilgiler.</a:t>
             </a:r>
           </a:p>
           <a:p xmlns:a="http://schemas.openxmlformats.org/drawingml/2006/main">
@@ -728,32 +688,22 @@
           <a:lstStyle xmlns:a="http://schemas.openxmlformats.org/drawingml/2006/main"/>
           <a:p xmlns:a="http://schemas.openxmlformats.org/drawingml/2006/main">
             <a:r>
-              <a:t>İlk sürüm oynanıyordu ama menü bir masaüstü programı gibi görünüyordu. Sadece rengi değiştirmenin yetmeyeceği açıktı.</a:t>
-            </a:r>
-          </a:p>
-          <a:p xmlns:a="http://schemas.openxmlformats.org/drawingml/2006/main">
-            <a:r>
-              <a:t>Bu yüzden başlık, buton sırası, tipografi ve hareket hissini birlikte ele aldım. Ekran görüntülerinde fark doğrudan görülüyor.</a:t>
-            </a:r>
-          </a:p>
-          <a:p xmlns:a="http://schemas.openxmlformats.org/drawingml/2006/main">
-            <a:r>
-              <a:t/>
-            </a:r>
-          </a:p>
-          <a:p xmlns:a="http://schemas.openxmlformats.org/drawingml/2006/main">
-            <a:r>
               <a:t>[Sources]</a:t>
             </a:r>
           </a:p>
           <a:p xmlns:a="http://schemas.openxmlformats.org/drawingml/2006/main">
             <a:r>
-              <a:t>İlk sürüm ekranı: D:/tusasgame/design-qa-artifacts/baseline-menu.png</a:t>
-            </a:r>
-          </a:p>
-          <a:p xmlns:a="http://schemas.openxmlformats.org/drawingml/2006/main">
-            <a:r>
-              <a:t>Güncel ekran: D:/tusasgame/design-qa-artifacts/final-menu.png</a:t>
+              <a:t>İlk sürüm: Git commit ab06a93 / public/games/blue-rescue.</a:t>
+            </a:r>
+          </a:p>
+          <a:p xmlns:a="http://schemas.openxmlformats.org/drawingml/2006/main">
+            <a:r>
+              <a:t>İlk sürüm oynanışı: D:/tusasgame/.presentation-revision-20260903/first-version-gameplay-compact.png</a:t>
+            </a:r>
+          </a:p>
+          <a:p xmlns:a="http://schemas.openxmlformats.org/drawingml/2006/main">
+            <a:r>
+              <a:t>Güncel oynanış: D:/tusasgame/.presentation-revision-20260903/current-gameplay-compact.png</a:t>
             </a:r>
           </a:p>
         </p:txBody>
@@ -823,21 +773,6 @@
           <a:lstStyle xmlns:a="http://schemas.openxmlformats.org/drawingml/2006/main"/>
           <a:p xmlns:a="http://schemas.openxmlformats.org/drawingml/2006/main">
             <a:r>
-              <a:t>Oyunun kapsamını özellikle küçük tuttum. Tek dokunuşla yükselip alçalma, kurtarma alanına yaklaşma, engellerden kaçma ve skor-seri takibi ana döngü olarak kaldı.</a:t>
-            </a:r>
-          </a:p>
-          <a:p xmlns:a="http://schemas.openxmlformats.org/drawingml/2006/main">
-            <a:r>
-              <a:t>Böylece yeni sistem eklemek yerine aynı döngünün anlaşılır ve tekrar oynanabilir olmasına odaklandım.</a:t>
-            </a:r>
-          </a:p>
-          <a:p xmlns:a="http://schemas.openxmlformats.org/drawingml/2006/main">
-            <a:r>
-              <a:t/>
-            </a:r>
-          </a:p>
-          <a:p xmlns:a="http://schemas.openxmlformats.org/drawingml/2006/main">
-            <a:r>
               <a:t>[Sources]</a:t>
             </a:r>
           </a:p>
@@ -913,27 +848,12 @@
           <a:lstStyle xmlns:a="http://schemas.openxmlformats.org/drawingml/2006/main"/>
           <a:p xmlns:a="http://schemas.openxmlformats.org/drawingml/2006/main">
             <a:r>
-              <a:t>Buradaki en önemli ders, oyunu büyütmekle oyunu iyileştirmenin aynı şey olmadığıydı.</a:t>
-            </a:r>
-          </a:p>
-          <a:p xmlns:a="http://schemas.openxmlformats.org/drawingml/2006/main">
-            <a:r>
-              <a:t>Eğim, rotor, kurtarma vurgusu, combo tepkisi ve çarpışma geri bildirimi gibi küçük ayrıntılar mevcut oynanışı daha anlaşılır ve canlı yaptı.</a:t>
-            </a:r>
-          </a:p>
-          <a:p xmlns:a="http://schemas.openxmlformats.org/drawingml/2006/main">
-            <a:r>
-              <a:t/>
-            </a:r>
-          </a:p>
-          <a:p xmlns:a="http://schemas.openxmlformats.org/drawingml/2006/main">
-            <a:r>
               <a:t>[Sources]</a:t>
             </a:r>
           </a:p>
           <a:p xmlns:a="http://schemas.openxmlformats.org/drawingml/2006/main">
             <a:r>
-              <a:t>Oyun davranışları: D:/tusasgame/game.js ve game-core.js</a:t>
+              <a:t>Oyun davranışları: D:/tusasgame/game.js ve D:/tusasgame/game-core.js</a:t>
             </a:r>
           </a:p>
           <a:p xmlns:a="http://schemas.openxmlformats.org/drawingml/2006/main">
@@ -1008,27 +928,12 @@
           <a:lstStyle xmlns:a="http://schemas.openxmlformats.org/drawingml/2006/main"/>
           <a:p xmlns:a="http://schemas.openxmlformats.org/drawingml/2006/main">
             <a:r>
-              <a:t>Blue Rescue'ın SKY Olimpiyatları için anlamı burada: klasik bir staj raporu yerine, neden yaptığımı açıklayabildiğim ve doğrudan oynatabildiğim bir proje çıktı.</a:t>
-            </a:r>
-          </a:p>
-          <a:p xmlns:a="http://schemas.openxmlformats.org/drawingml/2006/main">
-            <a:r>
-              <a:t>Sunumdan sonra oyunu QR koduyla hemen deneyebilirsiniz.</a:t>
-            </a:r>
-          </a:p>
-          <a:p xmlns:a="http://schemas.openxmlformats.org/drawingml/2006/main">
-            <a:r>
-              <a:t/>
-            </a:r>
-          </a:p>
-          <a:p xmlns:a="http://schemas.openxmlformats.org/drawingml/2006/main">
-            <a:r>
               <a:t>[Sources]</a:t>
             </a:r>
           </a:p>
           <a:p xmlns:a="http://schemas.openxmlformats.org/drawingml/2006/main">
             <a:r>
-              <a:t>Canlı demo: https://volitanlabs.dev/tr/blue-rescue</a:t>
+              <a:t>Canlı demo ve kişisel site: https://www.volitanlabs.dev/tr/blue-rescue</a:t>
             </a:r>
           </a:p>
           <a:p xmlns:a="http://schemas.openxmlformats.org/drawingml/2006/main">
@@ -1101,7 +1006,7 @@
   </p:cSld>
   <p:clrMap bg1="lt1" tx1="dk1" bg2="lt2" tx2="dk2" accent1="accent1" accent2="accent2" accent3="accent3" accent4="accent4" accent5="accent5" accent6="accent6" hlink="hlink" folHlink="folHlink"/>
   <p:sldLayoutIdLst>
-    <p:sldLayoutId xmlns:r="http://schemas.openxmlformats.org/officeDocument/2006/relationships" id="2147483649" r:id="R7a22af583bad4824"/>
+    <p:sldLayoutId xmlns:r="http://schemas.openxmlformats.org/officeDocument/2006/relationships" id="2147483649" r:id="R19142873795a490d"/>
   </p:sldLayoutIdLst>
   <p:txStyles>
     <p:titleStyle>
@@ -1711,6 +1616,7 @@
           <a:lstStyle xmlns:a="http://schemas.openxmlformats.org/drawingml/2006/main"/>
           <a:p xmlns:a="http://schemas.openxmlformats.org/drawingml/2006/main">
             <a:pPr algn="l">
+              <a:buNone/>
               <a:defRPr sz="1500" b="1">
                 <a:solidFill>
                   <a:srgbClr val="36C2FF"/>
@@ -1723,7 +1629,7 @@
                   <a:srgbClr val="36C2FF"/>
                 </a:solidFill>
               </a:rPr>
-              <a:t>SKY OLİMPİYATLARI  /  2026</a:t>
+              <a:t>SKY OLİMPİYATLARI  /  2026 III. DÖNEM</a:t>
             </a:r>
           </a:p>
         </p:txBody>
@@ -1761,6 +1667,7 @@
           <a:lstStyle xmlns:a="http://schemas.openxmlformats.org/drawingml/2006/main"/>
           <a:p xmlns:a="http://schemas.openxmlformats.org/drawingml/2006/main">
             <a:pPr algn="l">
+              <a:buNone/>
               <a:defRPr sz="6900" b="1">
                 <a:solidFill>
                   <a:srgbClr val="36C2FF"/>
@@ -1811,6 +1718,7 @@
           <a:lstStyle xmlns:a="http://schemas.openxmlformats.org/drawingml/2006/main"/>
           <a:p xmlns:a="http://schemas.openxmlformats.org/drawingml/2006/main">
             <a:pPr algn="l">
+              <a:buNone/>
               <a:defRPr sz="8850" b="1">
                 <a:solidFill>
                   <a:srgbClr val="F5FAFF"/>
@@ -1861,6 +1769,7 @@
           <a:lstStyle xmlns:a="http://schemas.openxmlformats.org/drawingml/2006/main"/>
           <a:p xmlns:a="http://schemas.openxmlformats.org/drawingml/2006/main">
             <a:pPr algn="l">
+              <a:buNone/>
               <a:defRPr sz="2325" b="0">
                 <a:solidFill>
                   <a:srgbClr val="F5FAFF"/>
@@ -1878,6 +1787,7 @@
           </a:p>
           <a:p xmlns:a="http://schemas.openxmlformats.org/drawingml/2006/main">
             <a:pPr algn="l">
+              <a:buNone/>
               <a:defRPr sz="2325" b="0">
                 <a:solidFill>
                   <a:srgbClr val="F5FAFF"/>
@@ -1890,7 +1800,7 @@
                   <a:srgbClr val="F5FAFF"/>
                 </a:solidFill>
               </a:rPr>
-              <a:t>oynanabilen küçük bir fikir.</a:t>
+              <a:t>oynanabilir küçük bir proje.</a:t>
             </a:r>
           </a:p>
         </p:txBody>
@@ -1928,6 +1838,7 @@
           <a:lstStyle xmlns:a="http://schemas.openxmlformats.org/drawingml/2006/main"/>
           <a:p xmlns:a="http://schemas.openxmlformats.org/drawingml/2006/main">
             <a:pPr algn="l">
+              <a:buNone/>
               <a:defRPr sz="1650" b="1">
                 <a:solidFill>
                   <a:srgbClr val="A9C6DC"/>
@@ -1978,6 +1889,7 @@
           <a:lstStyle xmlns:a="http://schemas.openxmlformats.org/drawingml/2006/main"/>
           <a:p xmlns:a="http://schemas.openxmlformats.org/drawingml/2006/main">
             <a:pPr algn="l">
+              <a:buNone/>
               <a:defRPr sz="1575" b="0">
                 <a:solidFill>
                   <a:srgbClr val="F5FAFF"/>
@@ -2036,14 +1948,14 @@
       </p:sp>
       <p:pic>
         <p:nvPicPr>
-          <p:cNvPr id="18" name=""/>
+          <p:cNvPr id="20" name=""/>
           <p:cNvPicPr>
             <a:picLocks xmlns:a="http://schemas.openxmlformats.org/drawingml/2006/main" noChangeAspect="1"/>
           </p:cNvPicPr>
           <p:nvPr/>
         </p:nvPicPr>
         <p:blipFill>
-          <a:blip xmlns:r="http://schemas.openxmlformats.org/officeDocument/2006/relationships" xmlns:a="http://schemas.openxmlformats.org/drawingml/2006/main" r:embed="R327fc1e6f379456c"/>
+          <a:blip xmlns:r="http://schemas.openxmlformats.org/officeDocument/2006/relationships" xmlns:a="http://schemas.openxmlformats.org/drawingml/2006/main" r:embed="R1d706dca39394384"/>
           <a:srcRect xmlns:a="http://schemas.openxmlformats.org/drawingml/2006/main" l="0" t="4" r="0" b="4"/>
           <a:stretch xmlns:a="http://schemas.openxmlformats.org/drawingml/2006/main">
             <a:fillRect l="0" t="0" r="0" b="0"/>
@@ -2123,6 +2035,7 @@
           <a:lstStyle xmlns:a="http://schemas.openxmlformats.org/drawingml/2006/main"/>
           <a:p xmlns:a="http://schemas.openxmlformats.org/drawingml/2006/main">
             <a:pPr algn="l">
+              <a:buNone/>
               <a:defRPr sz="1350" b="1">
                 <a:solidFill>
                   <a:srgbClr val="36C2FF"/>
@@ -2135,7 +2048,7 @@
                   <a:srgbClr val="36C2FF"/>
                 </a:solidFill>
               </a:rPr>
-              <a:t>NEDEN BU PROJE?</a:t>
+              <a:t>1. GÖREV  /  OECD YETKİNLİK KANITI</a:t>
             </a:r>
           </a:p>
         </p:txBody>
@@ -2173,6 +2086,7 @@
           <a:lstStyle xmlns:a="http://schemas.openxmlformats.org/drawingml/2006/main"/>
           <a:p xmlns:a="http://schemas.openxmlformats.org/drawingml/2006/main">
             <a:pPr algn="l">
+              <a:buNone/>
               <a:defRPr sz="4050" b="1">
                 <a:solidFill>
                   <a:srgbClr val="F5FAFF"/>
@@ -2185,7 +2099,7 @@
                   <a:srgbClr val="F5FAFF"/>
                 </a:solidFill>
               </a:rPr>
-              <a:t>Beklenen yol belliydi.</a:t>
+              <a:t>Seçtiğim yetkinlik:</a:t>
             </a:r>
           </a:p>
         </p:txBody>
@@ -2223,6 +2137,7 @@
           <a:lstStyle xmlns:a="http://schemas.openxmlformats.org/drawingml/2006/main"/>
           <a:p xmlns:a="http://schemas.openxmlformats.org/drawingml/2006/main">
             <a:pPr algn="l">
+              <a:buNone/>
               <a:defRPr sz="2850" b="1">
                 <a:solidFill>
                   <a:srgbClr val="A9C6DC"/>
@@ -2235,11 +2150,12 @@
                   <a:srgbClr val="A9C6DC"/>
                 </a:solidFill>
               </a:rPr>
-              <a:t>Isıl analizle ilgili</a:t>
-            </a:r>
-          </a:p>
-          <a:p xmlns:a="http://schemas.openxmlformats.org/drawingml/2006/main">
-            <a:pPr algn="l">
+              <a:t>Yaratıcılık ve</a:t>
+            </a:r>
+          </a:p>
+          <a:p xmlns:a="http://schemas.openxmlformats.org/drawingml/2006/main">
+            <a:pPr algn="l">
+              <a:buNone/>
               <a:defRPr sz="2850" b="1">
                 <a:solidFill>
                   <a:srgbClr val="A9C6DC"/>
@@ -2252,7 +2168,7 @@
                   <a:srgbClr val="A9C6DC"/>
                 </a:solidFill>
               </a:rPr>
-              <a:t>normal bir staj konusu</a:t>
+              <a:t>İnovasyon</a:t>
             </a:r>
           </a:p>
         </p:txBody>
@@ -2321,6 +2237,7 @@
           <a:lstStyle xmlns:a="http://schemas.openxmlformats.org/drawingml/2006/main"/>
           <a:p xmlns:a="http://schemas.openxmlformats.org/drawingml/2006/main">
             <a:pPr algn="l">
+              <a:buNone/>
               <a:defRPr sz="1950" b="0">
                 <a:solidFill>
                   <a:srgbClr val="F5FAFF"/>
@@ -2333,11 +2250,12 @@
                   <a:srgbClr val="F5FAFF"/>
                 </a:solidFill>
               </a:rPr>
-              <a:t>Ama bu, tahmin edilmesi</a:t>
-            </a:r>
-          </a:p>
-          <a:p xmlns:a="http://schemas.openxmlformats.org/drawingml/2006/main">
-            <a:pPr algn="l">
+              <a:t>Yetkinliği anlatmak yerine,</a:t>
+            </a:r>
+          </a:p>
+          <a:p xmlns:a="http://schemas.openxmlformats.org/drawingml/2006/main">
+            <a:pPr algn="l">
+              <a:buNone/>
               <a:defRPr sz="1950" b="0">
                 <a:solidFill>
                   <a:srgbClr val="F5FAFF"/>
@@ -2350,7 +2268,7 @@
                   <a:srgbClr val="F5FAFF"/>
                 </a:solidFill>
               </a:rPr>
-              <a:t>çok kolay bir sunum olurdu.</a:t>
+              <a:t>çalışan bir projeyle gösteriyorum.</a:t>
             </a:r>
           </a:p>
         </p:txBody>
@@ -2419,6 +2337,7 @@
           <a:lstStyle xmlns:a="http://schemas.openxmlformats.org/drawingml/2006/main"/>
           <a:p xmlns:a="http://schemas.openxmlformats.org/drawingml/2006/main">
             <a:pPr algn="l">
+              <a:buNone/>
               <a:defRPr sz="1500" b="1">
                 <a:solidFill>
                   <a:srgbClr val="FF6A3D"/>
@@ -2431,7 +2350,7 @@
                   <a:srgbClr val="FF6A3D"/>
                 </a:solidFill>
               </a:rPr>
-              <a:t>BENİM SEÇİMİM</a:t>
+              <a:t>NEDEN OYUN?</a:t>
             </a:r>
           </a:p>
         </p:txBody>
@@ -2469,6 +2388,7 @@
           <a:lstStyle xmlns:a="http://schemas.openxmlformats.org/drawingml/2006/main"/>
           <a:p xmlns:a="http://schemas.openxmlformats.org/drawingml/2006/main">
             <a:pPr algn="l">
+              <a:buNone/>
               <a:defRPr sz="4350" b="1">
                 <a:solidFill>
                   <a:srgbClr val="F5FAFF"/>
@@ -2486,6 +2406,7 @@
           </a:p>
           <a:p xmlns:a="http://schemas.openxmlformats.org/drawingml/2006/main">
             <a:pPr algn="l">
+              <a:buNone/>
               <a:defRPr sz="4350" b="1">
                 <a:solidFill>
                   <a:srgbClr val="F5FAFF"/>
@@ -2536,6 +2457,7 @@
           <a:lstStyle xmlns:a="http://schemas.openxmlformats.org/drawingml/2006/main"/>
           <a:p xmlns:a="http://schemas.openxmlformats.org/drawingml/2006/main">
             <a:pPr algn="l">
+              <a:buNone/>
               <a:defRPr sz="2025" b="0">
                 <a:solidFill>
                   <a:srgbClr val="A9C6DC"/>
@@ -2548,11 +2470,12 @@
                   <a:srgbClr val="A9C6DC"/>
                 </a:solidFill>
               </a:rPr>
-              <a:t>Kısa sürede anlaşılabilen,</a:t>
-            </a:r>
-          </a:p>
-          <a:p xmlns:a="http://schemas.openxmlformats.org/drawingml/2006/main">
-            <a:pPr algn="l">
+              <a:t>Isıl analiz odaklı bir staj sunumu beklenebilir.</a:t>
+            </a:r>
+          </a:p>
+          <a:p xmlns:a="http://schemas.openxmlformats.org/drawingml/2006/main">
+            <a:pPr algn="l">
+              <a:buNone/>
               <a:defRPr sz="2025" b="0">
                 <a:solidFill>
                   <a:srgbClr val="A9C6DC"/>
@@ -2565,24 +2488,7 @@
                   <a:srgbClr val="A9C6DC"/>
                 </a:solidFill>
               </a:rPr>
-              <a:t>oynanabilen ve sunum bittiğinde</a:t>
-            </a:r>
-          </a:p>
-          <a:p xmlns:a="http://schemas.openxmlformats.org/drawingml/2006/main">
-            <a:pPr algn="l">
-              <a:defRPr sz="2025" b="0">
-                <a:solidFill>
-                  <a:srgbClr val="A9C6DC"/>
-                </a:solidFill>
-              </a:defRPr>
-            </a:pPr>
-            <a:r>
-              <a:rPr sz="2025" b="0">
-                <a:solidFill>
-                  <a:srgbClr val="A9C6DC"/>
-                </a:solidFill>
-              </a:rPr>
-              <a:t>akılda kalan bir şey.</a:t>
+              <a:t>Ben daha etkileşimli ve akılda kalan bir format seçiyorum.</a:t>
             </a:r>
           </a:p>
         </p:txBody>
@@ -2620,6 +2526,7 @@
           <a:lstStyle xmlns:a="http://schemas.openxmlformats.org/drawingml/2006/main"/>
           <a:p xmlns:a="http://schemas.openxmlformats.org/drawingml/2006/main">
             <a:pPr algn="l">
+              <a:buNone/>
               <a:defRPr sz="1800" b="1">
                 <a:solidFill>
                   <a:srgbClr val="36C2FF"/>
@@ -2632,7 +2539,7 @@
                   <a:srgbClr val="36C2FF"/>
                 </a:solidFill>
               </a:rPr>
-              <a:t>Yani konu değişmedi; anlatma biçimi değişti.</a:t>
+              <a:t>Destekleyen beceriler: Problem çözme · Dijital okuryazarlık</a:t>
             </a:r>
           </a:p>
         </p:txBody>
@@ -2701,6 +2608,7 @@
           <a:lstStyle xmlns:a="http://schemas.openxmlformats.org/drawingml/2006/main"/>
           <a:p xmlns:a="http://schemas.openxmlformats.org/drawingml/2006/main">
             <a:pPr algn="l">
+              <a:buNone/>
               <a:defRPr sz="1050" b="1">
                 <a:solidFill>
                   <a:srgbClr val="A9C6DC"/>
@@ -2751,6 +2659,7 @@
           <a:lstStyle xmlns:a="http://schemas.openxmlformats.org/drawingml/2006/main"/>
           <a:p xmlns:a="http://schemas.openxmlformats.org/drawingml/2006/main">
             <a:pPr algn="r">
+              <a:buNone/>
               <a:defRPr sz="1050" b="1">
                 <a:solidFill>
                   <a:srgbClr val="A9C6DC"/>
@@ -2830,6 +2739,7 @@
           <a:lstStyle xmlns:a="http://schemas.openxmlformats.org/drawingml/2006/main"/>
           <a:p xmlns:a="http://schemas.openxmlformats.org/drawingml/2006/main">
             <a:pPr algn="l">
+              <a:buNone/>
               <a:defRPr sz="1350" b="1">
                 <a:solidFill>
                   <a:srgbClr val="36C2FF"/>
@@ -2880,6 +2790,7 @@
           <a:lstStyle xmlns:a="http://schemas.openxmlformats.org/drawingml/2006/main"/>
           <a:p xmlns:a="http://schemas.openxmlformats.org/drawingml/2006/main">
             <a:pPr algn="l">
+              <a:buNone/>
               <a:defRPr sz="4350" b="1">
                 <a:solidFill>
                   <a:srgbClr val="F5FAFF"/>
@@ -2930,6 +2841,7 @@
           <a:lstStyle xmlns:a="http://schemas.openxmlformats.org/drawingml/2006/main"/>
           <a:p xmlns:a="http://schemas.openxmlformats.org/drawingml/2006/main">
             <a:pPr algn="l">
+              <a:buNone/>
               <a:defRPr sz="4950" b="1">
                 <a:solidFill>
                   <a:srgbClr val="36C2FF"/>
@@ -2947,6 +2859,7 @@
           </a:p>
           <a:p xmlns:a="http://schemas.openxmlformats.org/drawingml/2006/main">
             <a:pPr algn="l">
+              <a:buNone/>
               <a:defRPr sz="4950" b="1">
                 <a:solidFill>
                   <a:srgbClr val="36C2FF"/>
@@ -2997,6 +2910,7 @@
           <a:lstStyle xmlns:a="http://schemas.openxmlformats.org/drawingml/2006/main"/>
           <a:p xmlns:a="http://schemas.openxmlformats.org/drawingml/2006/main">
             <a:pPr algn="l">
+              <a:buNone/>
               <a:defRPr sz="2025" b="0">
                 <a:solidFill>
                   <a:srgbClr val="F5FAFF"/>
@@ -3009,11 +2923,12 @@
                   <a:srgbClr val="F5FAFF"/>
                 </a:solidFill>
               </a:rPr>
-              <a:t>Cevap bundan daha karmaşık değil.</a:t>
-            </a:r>
-          </a:p>
-          <a:p xmlns:a="http://schemas.openxmlformats.org/drawingml/2006/main">
-            <a:pPr algn="l">
+              <a:t>Şu anda GÖKBEY Isıl ve Akışkanlar Analizi stajındayım.</a:t>
+            </a:r>
+          </a:p>
+          <a:p xmlns:a="http://schemas.openxmlformats.org/drawingml/2006/main">
+            <a:pPr algn="l">
+              <a:buNone/>
               <a:defRPr sz="2025" b="0">
                 <a:solidFill>
                   <a:srgbClr val="F5FAFF"/>
@@ -3026,24 +2941,7 @@
                   <a:srgbClr val="F5FAFF"/>
                 </a:solidFill>
               </a:rPr>
-              <a:t>Staj yaptığım alanı oyunun temasına taşıdım;</a:t>
-            </a:r>
-          </a:p>
-          <a:p xmlns:a="http://schemas.openxmlformats.org/drawingml/2006/main">
-            <a:pPr algn="l">
-              <a:defRPr sz="2025" b="0">
-                <a:solidFill>
-                  <a:srgbClr val="F5FAFF"/>
-                </a:solidFill>
-              </a:defRPr>
-            </a:pPr>
-            <a:r>
-              <a:rPr sz="2025" b="0">
-                <a:solidFill>
-                  <a:srgbClr val="F5FAFF"/>
-                </a:solidFill>
-              </a:rPr>
-              <a:t>resmî bir simülasyon yapmaya çalışmadım.</a:t>
+              <a:t>Teknisyenlik dönemimde de GÖKBEY Prototip Projesi'nde çalıştım.</a:t>
             </a:r>
           </a:p>
         </p:txBody>
@@ -3081,6 +2979,7 @@
           <a:lstStyle xmlns:a="http://schemas.openxmlformats.org/drawingml/2006/main"/>
           <a:p xmlns:a="http://schemas.openxmlformats.org/drawingml/2006/main">
             <a:pPr algn="l">
+              <a:buNone/>
               <a:defRPr sz="1650" b="1">
                 <a:solidFill>
                   <a:srgbClr val="FF6A3D"/>
@@ -3093,7 +2992,7 @@
                   <a:srgbClr val="FF6A3D"/>
                 </a:solidFill>
               </a:rPr>
-              <a:t>Helikopter generic ve mavi kaldı. Odağım marka değil, oynanıştı.</a:t>
+              <a:t>Helikopter teması buradan geliyor; araç yine de genel ve mavi.</a:t>
             </a:r>
           </a:p>
         </p:txBody>
@@ -3139,14 +3038,14 @@
       </p:sp>
       <p:pic>
         <p:nvPicPr>
-          <p:cNvPr id="17" name=""/>
+          <p:cNvPr id="19" name=""/>
           <p:cNvPicPr>
             <a:picLocks xmlns:a="http://schemas.openxmlformats.org/drawingml/2006/main" noChangeAspect="1"/>
           </p:cNvPicPr>
           <p:nvPr/>
         </p:nvPicPr>
         <p:blipFill>
-          <a:blip xmlns:r="http://schemas.openxmlformats.org/officeDocument/2006/relationships" xmlns:a="http://schemas.openxmlformats.org/drawingml/2006/main" r:embed="R67e043283da34862"/>
+          <a:blip xmlns:r="http://schemas.openxmlformats.org/officeDocument/2006/relationships" xmlns:a="http://schemas.openxmlformats.org/drawingml/2006/main" r:embed="R3a2f5de30268446f"/>
           <a:srcRect xmlns:a="http://schemas.openxmlformats.org/drawingml/2006/main" l="0" t="1734" r="0" b="1734"/>
           <a:stretch xmlns:a="http://schemas.openxmlformats.org/drawingml/2006/main">
             <a:fillRect l="0" t="0" r="0" b="0"/>
@@ -3228,6 +3127,7 @@
           <a:lstStyle xmlns:a="http://schemas.openxmlformats.org/drawingml/2006/main"/>
           <a:p xmlns:a="http://schemas.openxmlformats.org/drawingml/2006/main">
             <a:pPr algn="l">
+              <a:buNone/>
               <a:defRPr sz="1050" b="1">
                 <a:solidFill>
                   <a:srgbClr val="A9C6DC"/>
@@ -3278,6 +3178,7 @@
           <a:lstStyle xmlns:a="http://schemas.openxmlformats.org/drawingml/2006/main"/>
           <a:p xmlns:a="http://schemas.openxmlformats.org/drawingml/2006/main">
             <a:pPr algn="r">
+              <a:buNone/>
               <a:defRPr sz="1050" b="1">
                 <a:solidFill>
                   <a:srgbClr val="A9C6DC"/>
@@ -3357,6 +3258,7 @@
           <a:lstStyle xmlns:a="http://schemas.openxmlformats.org/drawingml/2006/main"/>
           <a:p xmlns:a="http://schemas.openxmlformats.org/drawingml/2006/main">
             <a:pPr algn="l">
+              <a:buNone/>
               <a:defRPr sz="1350" b="1">
                 <a:solidFill>
                   <a:srgbClr val="36C2FF"/>
@@ -3407,6 +3309,7 @@
           <a:lstStyle xmlns:a="http://schemas.openxmlformats.org/drawingml/2006/main"/>
           <a:p xmlns:a="http://schemas.openxmlformats.org/drawingml/2006/main">
             <a:pPr algn="l">
+              <a:buNone/>
               <a:defRPr sz="3750" b="1">
                 <a:solidFill>
                   <a:srgbClr val="F5FAFF"/>
@@ -3419,11 +3322,12 @@
                   <a:srgbClr val="F5FAFF"/>
                 </a:solidFill>
               </a:rPr>
-              <a:t>İlk sürüm çalışıyordu;</a:t>
-            </a:r>
-          </a:p>
-          <a:p xmlns:a="http://schemas.openxmlformats.org/drawingml/2006/main">
-            <a:pPr algn="l">
+              <a:t>İlk prototipten</a:t>
+            </a:r>
+          </a:p>
+          <a:p xmlns:a="http://schemas.openxmlformats.org/drawingml/2006/main">
+            <a:pPr algn="l">
+              <a:buNone/>
               <a:defRPr sz="3750" b="1">
                 <a:solidFill>
                   <a:srgbClr val="F5FAFF"/>
@@ -3436,7 +3340,7 @@
                   <a:srgbClr val="F5FAFF"/>
                 </a:solidFill>
               </a:rPr>
-              <a:t>ama oyun gibi hissettirmiyordu.</a:t>
+              <a:t>güncel oyun deneyimine.</a:t>
             </a:r>
           </a:p>
         </p:txBody>
@@ -3457,8 +3361,8 @@
         </p:nvSpPr>
         <p:spPr>
           <a:xfrm xmlns:a="http://schemas.openxmlformats.org/drawingml/2006/main">
-            <a:off x="704850" y="2076450"/>
-            <a:ext cx="7143750" cy="590550"/>
+            <a:off x="800100" y="2076450"/>
+            <a:ext cx="10439400" cy="400050"/>
           </a:xfrm>
           <a:prstGeom xmlns:a="http://schemas.openxmlformats.org/drawingml/2006/main" prst="rect">
             <a:avLst/>
@@ -3474,6 +3378,7 @@
           <a:lstStyle xmlns:a="http://schemas.openxmlformats.org/drawingml/2006/main"/>
           <a:p xmlns:a="http://schemas.openxmlformats.org/drawingml/2006/main">
             <a:pPr algn="l">
+              <a:buNone/>
               <a:defRPr sz="1875" b="0">
                 <a:solidFill>
                   <a:srgbClr val="A9C6DC"/>
@@ -3486,7 +3391,7 @@
                   <a:srgbClr val="A9C6DC"/>
                 </a:solidFill>
               </a:rPr>
-              <a:t>Sorun renk değildi. Hiyerarşi, tipografi, hareket ve geri bildirim zayıftı.</a:t>
+              <a:t>Güncel sürümde hiyerarşi, tipografi, hareket ve geri bildirim birlikte çalışıyor.</a:t>
             </a:r>
           </a:p>
         </p:txBody>
@@ -3532,23 +3437,20 @@
       </p:sp>
       <p:pic>
         <p:nvPicPr>
-          <p:cNvPr id="19" name=""/>
+          <p:cNvPr id="22" name=""/>
           <p:cNvPicPr>
             <a:picLocks xmlns:a="http://schemas.openxmlformats.org/drawingml/2006/main" noChangeAspect="1"/>
           </p:cNvPicPr>
           <p:nvPr/>
         </p:nvPicPr>
         <p:blipFill>
-          <a:blip xmlns:r="http://schemas.openxmlformats.org/officeDocument/2006/relationships" xmlns:a="http://schemas.openxmlformats.org/drawingml/2006/main" r:embed="R7e91c00ef09b43c9"/>
-          <a:srcRect xmlns:a="http://schemas.openxmlformats.org/drawingml/2006/main" l="0" t="18074" r="0" b="18074"/>
-          <a:stretch xmlns:a="http://schemas.openxmlformats.org/drawingml/2006/main">
-            <a:fillRect l="0" t="0" r="0" b="0"/>
-          </a:stretch>
+          <a:blip xmlns:r="http://schemas.openxmlformats.org/officeDocument/2006/relationships" xmlns:a="http://schemas.openxmlformats.org/drawingml/2006/main" r:embed="Rcdbfc7cd3eda480c"/>
+          <a:stretch xmlns:a="http://schemas.openxmlformats.org/drawingml/2006/main"/>
         </p:blipFill>
         <p:spPr>
           <a:xfrm xmlns:a="http://schemas.openxmlformats.org/drawingml/2006/main">
-            <a:off x="1104900" y="3009900"/>
-            <a:ext cx="2095500" cy="2895600"/>
+            <a:off x="1480124" y="3009900"/>
+            <a:ext cx="1345053" cy="2895600"/>
           </a:xfrm>
           <a:prstGeom xmlns:a="http://schemas.openxmlformats.org/drawingml/2006/main" prst="roundRect">
             <a:avLst>
@@ -3590,6 +3492,7 @@
           <a:lstStyle xmlns:a="http://schemas.openxmlformats.org/drawingml/2006/main"/>
           <a:p xmlns:a="http://schemas.openxmlformats.org/drawingml/2006/main">
             <a:pPr algn="ctr">
+              <a:buNone/>
               <a:defRPr sz="1425" b="1">
                 <a:solidFill>
                   <a:srgbClr val="A9C6DC"/>
@@ -3640,6 +3543,7 @@
           <a:lstStyle xmlns:a="http://schemas.openxmlformats.org/drawingml/2006/main"/>
           <a:p xmlns:a="http://schemas.openxmlformats.org/drawingml/2006/main">
             <a:pPr algn="ctr">
+              <a:buNone/>
               <a:defRPr sz="4800" b="1">
                 <a:solidFill>
                   <a:srgbClr val="FF6A3D"/>
@@ -3698,23 +3602,20 @@
       </p:sp>
       <p:pic>
         <p:nvPicPr>
-          <p:cNvPr id="23" name=""/>
+          <p:cNvPr id="26" name=""/>
           <p:cNvPicPr>
             <a:picLocks xmlns:a="http://schemas.openxmlformats.org/drawingml/2006/main" noChangeAspect="1"/>
           </p:cNvPicPr>
           <p:nvPr/>
         </p:nvPicPr>
         <p:blipFill>
-          <a:blip xmlns:r="http://schemas.openxmlformats.org/officeDocument/2006/relationships" xmlns:a="http://schemas.openxmlformats.org/drawingml/2006/main" r:embed="R622a35b870b143b3"/>
-          <a:srcRect xmlns:a="http://schemas.openxmlformats.org/drawingml/2006/main" l="0" t="18209" r="0" b="18209"/>
-          <a:stretch xmlns:a="http://schemas.openxmlformats.org/drawingml/2006/main">
-            <a:fillRect l="0" t="0" r="0" b="0"/>
-          </a:stretch>
+          <a:blip xmlns:r="http://schemas.openxmlformats.org/officeDocument/2006/relationships" xmlns:a="http://schemas.openxmlformats.org/drawingml/2006/main" r:embed="Ra0509fe0ff6d45f6"/>
+          <a:stretch xmlns:a="http://schemas.openxmlformats.org/drawingml/2006/main"/>
         </p:blipFill>
         <p:spPr>
           <a:xfrm xmlns:a="http://schemas.openxmlformats.org/drawingml/2006/main">
-            <a:off x="5295900" y="2819400"/>
-            <a:ext cx="2381250" cy="3276600"/>
+            <a:off x="5455981" y="2819400"/>
+            <a:ext cx="2061087" cy="3276600"/>
           </a:xfrm>
           <a:prstGeom xmlns:a="http://schemas.openxmlformats.org/drawingml/2006/main" prst="roundRect">
             <a:avLst>
@@ -3756,6 +3657,7 @@
           <a:lstStyle xmlns:a="http://schemas.openxmlformats.org/drawingml/2006/main"/>
           <a:p xmlns:a="http://schemas.openxmlformats.org/drawingml/2006/main">
             <a:pPr algn="ctr">
+              <a:buNone/>
               <a:defRPr sz="1425" b="1">
                 <a:solidFill>
                   <a:srgbClr val="36C2FF"/>
@@ -3806,6 +3708,7 @@
           <a:lstStyle xmlns:a="http://schemas.openxmlformats.org/drawingml/2006/main"/>
           <a:p xmlns:a="http://schemas.openxmlformats.org/drawingml/2006/main">
             <a:pPr algn="l">
+              <a:buNone/>
               <a:defRPr sz="2025" b="1">
                 <a:solidFill>
                   <a:srgbClr val="F5FAFF"/>
@@ -3818,11 +3721,12 @@
                   <a:srgbClr val="F5FAFF"/>
                 </a:solidFill>
               </a:rPr>
-              <a:t>Daha net başlık</a:t>
-            </a:r>
-          </a:p>
-          <a:p xmlns:a="http://schemas.openxmlformats.org/drawingml/2006/main">
-            <a:pPr algn="l">
+              <a:t>Daha temiz HUD</a:t>
+            </a:r>
+          </a:p>
+          <a:p xmlns:a="http://schemas.openxmlformats.org/drawingml/2006/main">
+            <a:pPr algn="l">
+              <a:buNone/>
               <a:defRPr sz="2025" b="1">
                 <a:solidFill>
                   <a:srgbClr val="F5FAFF"/>
@@ -3835,11 +3739,12 @@
                   <a:srgbClr val="F5FAFF"/>
                 </a:solidFill>
               </a:rPr>
-              <a:t>Tek güçlü başlangıç butonu</a:t>
-            </a:r>
-          </a:p>
-          <a:p xmlns:a="http://schemas.openxmlformats.org/drawingml/2006/main">
-            <a:pPr algn="l">
+              <a:t>Eğimli helikopter hareketi</a:t>
+            </a:r>
+          </a:p>
+          <a:p xmlns:a="http://schemas.openxmlformats.org/drawingml/2006/main">
+            <a:pPr algn="l">
+              <a:buNone/>
               <a:defRPr sz="2025" b="1">
                 <a:solidFill>
                   <a:srgbClr val="F5FAFF"/>
@@ -3852,11 +3757,12 @@
                   <a:srgbClr val="F5FAFF"/>
                 </a:solidFill>
               </a:rPr>
-              <a:t>Hareketli helikopter ve rotor</a:t>
-            </a:r>
-          </a:p>
-          <a:p xmlns:a="http://schemas.openxmlformats.org/drawingml/2006/main">
-            <a:pPr algn="l">
+              <a:t>Canlı rotor ve geri bildirim</a:t>
+            </a:r>
+          </a:p>
+          <a:p xmlns:a="http://schemas.openxmlformats.org/drawingml/2006/main">
+            <a:pPr algn="l">
+              <a:buNone/>
               <a:defRPr sz="2025" b="1">
                 <a:solidFill>
                   <a:srgbClr val="F5FAFF"/>
@@ -3869,7 +3775,7 @@
                   <a:srgbClr val="F5FAFF"/>
                 </a:solidFill>
               </a:rPr>
-              <a:t>Daha okunaklı bilgi sırası</a:t>
+              <a:t>Skor, seri ve kurtarma vurgusu</a:t>
             </a:r>
           </a:p>
         </p:txBody>
@@ -3938,6 +3844,7 @@
           <a:lstStyle xmlns:a="http://schemas.openxmlformats.org/drawingml/2006/main"/>
           <a:p xmlns:a="http://schemas.openxmlformats.org/drawingml/2006/main">
             <a:pPr algn="l">
+              <a:buNone/>
               <a:defRPr sz="1050" b="1">
                 <a:solidFill>
                   <a:srgbClr val="A9C6DC"/>
@@ -3988,6 +3895,7 @@
           <a:lstStyle xmlns:a="http://schemas.openxmlformats.org/drawingml/2006/main"/>
           <a:p xmlns:a="http://schemas.openxmlformats.org/drawingml/2006/main">
             <a:pPr algn="r">
+              <a:buNone/>
               <a:defRPr sz="1050" b="1">
                 <a:solidFill>
                   <a:srgbClr val="A9C6DC"/>
@@ -4067,6 +3975,7 @@
           <a:lstStyle xmlns:a="http://schemas.openxmlformats.org/drawingml/2006/main"/>
           <a:p xmlns:a="http://schemas.openxmlformats.org/drawingml/2006/main">
             <a:pPr algn="l">
+              <a:buNone/>
               <a:defRPr sz="1350" b="1">
                 <a:solidFill>
                   <a:srgbClr val="36C2FF"/>
@@ -4117,6 +4026,7 @@
           <a:lstStyle xmlns:a="http://schemas.openxmlformats.org/drawingml/2006/main"/>
           <a:p xmlns:a="http://schemas.openxmlformats.org/drawingml/2006/main">
             <a:pPr algn="l">
+              <a:buNone/>
               <a:defRPr sz="4350" b="1">
                 <a:solidFill>
                   <a:srgbClr val="F5FAFF"/>
@@ -4129,7 +4039,7 @@
                   <a:srgbClr val="F5FAFF"/>
                 </a:solidFill>
               </a:rPr>
-              <a:t>Döngü basit kaldı.</a:t>
+              <a:t>Oyun döngüsü net ve hızlı.</a:t>
             </a:r>
           </a:p>
         </p:txBody>
@@ -4167,6 +4077,7 @@
           <a:lstStyle xmlns:a="http://schemas.openxmlformats.org/drawingml/2006/main"/>
           <a:p xmlns:a="http://schemas.openxmlformats.org/drawingml/2006/main">
             <a:pPr algn="l">
+              <a:buNone/>
               <a:defRPr sz="1950" b="0">
                 <a:solidFill>
                   <a:srgbClr val="A9C6DC"/>
@@ -4225,14 +4136,14 @@
       </p:sp>
       <p:pic>
         <p:nvPicPr>
-          <p:cNvPr id="23" name=""/>
+          <p:cNvPr id="27" name=""/>
           <p:cNvPicPr>
             <a:picLocks xmlns:a="http://schemas.openxmlformats.org/drawingml/2006/main" noChangeAspect="1"/>
           </p:cNvPicPr>
           <p:nvPr/>
         </p:nvPicPr>
         <p:blipFill>
-          <a:blip xmlns:r="http://schemas.openxmlformats.org/officeDocument/2006/relationships" xmlns:a="http://schemas.openxmlformats.org/drawingml/2006/main" r:embed="R555275b523104fa9"/>
+          <a:blip xmlns:r="http://schemas.openxmlformats.org/officeDocument/2006/relationships" xmlns:a="http://schemas.openxmlformats.org/drawingml/2006/main" r:embed="R5aa2e01b03124649"/>
           <a:srcRect xmlns:a="http://schemas.openxmlformats.org/drawingml/2006/main" l="0" t="18308" r="0" b="18308"/>
           <a:stretch xmlns:a="http://schemas.openxmlformats.org/drawingml/2006/main">
             <a:fillRect l="0" t="0" r="0" b="0"/>
@@ -4283,6 +4194,7 @@
           <a:lstStyle xmlns:a="http://schemas.openxmlformats.org/drawingml/2006/main"/>
           <a:p xmlns:a="http://schemas.openxmlformats.org/drawingml/2006/main">
             <a:pPr algn="l">
+              <a:buNone/>
               <a:defRPr sz="1500" b="1">
                 <a:solidFill>
                   <a:srgbClr val="FF6A3D"/>
@@ -4333,6 +4245,7 @@
           <a:lstStyle xmlns:a="http://schemas.openxmlformats.org/drawingml/2006/main"/>
           <a:p xmlns:a="http://schemas.openxmlformats.org/drawingml/2006/main">
             <a:pPr algn="l">
+              <a:buNone/>
               <a:defRPr sz="1500" b="1">
                 <a:solidFill>
                   <a:srgbClr val="F5FAFF"/>
@@ -4391,14 +4304,14 @@
       </p:sp>
       <p:pic>
         <p:nvPicPr>
-          <p:cNvPr id="27" name=""/>
+          <p:cNvPr id="31" name=""/>
           <p:cNvPicPr>
             <a:picLocks xmlns:a="http://schemas.openxmlformats.org/drawingml/2006/main" noChangeAspect="1"/>
           </p:cNvPicPr>
           <p:nvPr/>
         </p:nvPicPr>
         <p:blipFill>
-          <a:blip xmlns:r="http://schemas.openxmlformats.org/officeDocument/2006/relationships" xmlns:a="http://schemas.openxmlformats.org/drawingml/2006/main" r:embed="Rd61fe12b22cc4501"/>
+          <a:blip xmlns:r="http://schemas.openxmlformats.org/officeDocument/2006/relationships" xmlns:a="http://schemas.openxmlformats.org/drawingml/2006/main" r:embed="Rd4897cc56392456e"/>
           <a:srcRect xmlns:a="http://schemas.openxmlformats.org/drawingml/2006/main" l="0" t="18308" r="0" b="18308"/>
           <a:stretch xmlns:a="http://schemas.openxmlformats.org/drawingml/2006/main">
             <a:fillRect l="0" t="0" r="0" b="0"/>
@@ -4449,6 +4362,7 @@
           <a:lstStyle xmlns:a="http://schemas.openxmlformats.org/drawingml/2006/main"/>
           <a:p xmlns:a="http://schemas.openxmlformats.org/drawingml/2006/main">
             <a:pPr algn="l">
+              <a:buNone/>
               <a:defRPr sz="1500" b="1">
                 <a:solidFill>
                   <a:srgbClr val="FF6A3D"/>
@@ -4499,6 +4413,7 @@
           <a:lstStyle xmlns:a="http://schemas.openxmlformats.org/drawingml/2006/main"/>
           <a:p xmlns:a="http://schemas.openxmlformats.org/drawingml/2006/main">
             <a:pPr algn="l">
+              <a:buNone/>
               <a:defRPr sz="1500" b="1">
                 <a:solidFill>
                   <a:srgbClr val="F5FAFF"/>
@@ -4557,14 +4472,14 @@
       </p:sp>
       <p:pic>
         <p:nvPicPr>
-          <p:cNvPr id="31" name=""/>
+          <p:cNvPr id="35" name=""/>
           <p:cNvPicPr>
             <a:picLocks xmlns:a="http://schemas.openxmlformats.org/drawingml/2006/main" noChangeAspect="1"/>
           </p:cNvPicPr>
           <p:nvPr/>
         </p:nvPicPr>
         <p:blipFill>
-          <a:blip xmlns:r="http://schemas.openxmlformats.org/officeDocument/2006/relationships" xmlns:a="http://schemas.openxmlformats.org/drawingml/2006/main" r:embed="R9cd5c3c4d2724ac6"/>
+          <a:blip xmlns:r="http://schemas.openxmlformats.org/officeDocument/2006/relationships" xmlns:a="http://schemas.openxmlformats.org/drawingml/2006/main" r:embed="R21fbed5aab834d41"/>
           <a:srcRect xmlns:a="http://schemas.openxmlformats.org/drawingml/2006/main" l="0" t="18308" r="0" b="18308"/>
           <a:stretch xmlns:a="http://schemas.openxmlformats.org/drawingml/2006/main">
             <a:fillRect l="0" t="0" r="0" b="0"/>
@@ -4615,6 +4530,7 @@
           <a:lstStyle xmlns:a="http://schemas.openxmlformats.org/drawingml/2006/main"/>
           <a:p xmlns:a="http://schemas.openxmlformats.org/drawingml/2006/main">
             <a:pPr algn="l">
+              <a:buNone/>
               <a:defRPr sz="1500" b="1">
                 <a:solidFill>
                   <a:srgbClr val="FF6A3D"/>
@@ -4665,6 +4581,7 @@
           <a:lstStyle xmlns:a="http://schemas.openxmlformats.org/drawingml/2006/main"/>
           <a:p xmlns:a="http://schemas.openxmlformats.org/drawingml/2006/main">
             <a:pPr algn="l">
+              <a:buNone/>
               <a:defRPr sz="1500" b="1">
                 <a:solidFill>
                   <a:srgbClr val="F5FAFF"/>
@@ -4746,6 +4663,7 @@
           <a:lstStyle xmlns:a="http://schemas.openxmlformats.org/drawingml/2006/main"/>
           <a:p xmlns:a="http://schemas.openxmlformats.org/drawingml/2006/main">
             <a:pPr algn="l">
+              <a:buNone/>
               <a:defRPr sz="1050" b="1">
                 <a:solidFill>
                   <a:srgbClr val="A9C6DC"/>
@@ -4796,6 +4714,7 @@
           <a:lstStyle xmlns:a="http://schemas.openxmlformats.org/drawingml/2006/main"/>
           <a:p xmlns:a="http://schemas.openxmlformats.org/drawingml/2006/main">
             <a:pPr algn="r">
+              <a:buNone/>
               <a:defRPr sz="1050" b="1">
                 <a:solidFill>
                   <a:srgbClr val="A9C6DC"/>
@@ -4875,6 +4794,7 @@
           <a:lstStyle xmlns:a="http://schemas.openxmlformats.org/drawingml/2006/main"/>
           <a:p xmlns:a="http://schemas.openxmlformats.org/drawingml/2006/main">
             <a:pPr algn="l">
+              <a:buNone/>
               <a:defRPr sz="1350" b="1">
                 <a:solidFill>
                   <a:srgbClr val="36C2FF"/>
@@ -4925,6 +4845,7 @@
           <a:lstStyle xmlns:a="http://schemas.openxmlformats.org/drawingml/2006/main"/>
           <a:p xmlns:a="http://schemas.openxmlformats.org/drawingml/2006/main">
             <a:pPr algn="l">
+              <a:buNone/>
               <a:defRPr sz="4350" b="1">
                 <a:solidFill>
                   <a:srgbClr val="F5FAFF"/>
@@ -4937,11 +4858,12 @@
                   <a:srgbClr val="F5FAFF"/>
                 </a:solidFill>
               </a:rPr>
-              <a:t>Son dokunuşlar,</a:t>
-            </a:r>
-          </a:p>
-          <a:p xmlns:a="http://schemas.openxmlformats.org/drawingml/2006/main">
-            <a:pPr algn="l">
+              <a:t>Her hareket</a:t>
+            </a:r>
+          </a:p>
+          <a:p xmlns:a="http://schemas.openxmlformats.org/drawingml/2006/main">
+            <a:pPr algn="l">
+              <a:buNone/>
               <a:defRPr sz="4350" b="1">
                 <a:solidFill>
                   <a:srgbClr val="F5FAFF"/>
@@ -4954,7 +4876,7 @@
                   <a:srgbClr val="F5FAFF"/>
                 </a:solidFill>
               </a:rPr>
-              <a:t>oyunu değiştirdi.</a:t>
+              <a:t>karşılığını veriyor.</a:t>
             </a:r>
           </a:p>
         </p:txBody>
@@ -4992,6 +4914,7 @@
           <a:lstStyle xmlns:a="http://schemas.openxmlformats.org/drawingml/2006/main"/>
           <a:p xmlns:a="http://schemas.openxmlformats.org/drawingml/2006/main">
             <a:pPr algn="l">
+              <a:buNone/>
               <a:defRPr sz="1950" b="0">
                 <a:solidFill>
                   <a:srgbClr val="A9C6DC"/>
@@ -5004,7 +4927,7 @@
                   <a:srgbClr val="A9C6DC"/>
                 </a:solidFill>
               </a:rPr>
-              <a:t>Yeni özelliklerden çok, mevcut anların daha iyi hissettirmesine çalıştım.</a:t>
+              <a:t>Yeni sistemlerden çok, her hareketin net bir karşılık vermesi önemli.</a:t>
             </a:r>
           </a:p>
         </p:txBody>
@@ -5073,6 +4996,7 @@
           <a:lstStyle xmlns:a="http://schemas.openxmlformats.org/drawingml/2006/main"/>
           <a:p xmlns:a="http://schemas.openxmlformats.org/drawingml/2006/main">
             <a:pPr algn="l">
+              <a:buNone/>
               <a:defRPr sz="1725" b="0">
                 <a:solidFill>
                   <a:srgbClr val="F5FAFF"/>
@@ -5090,6 +5014,7 @@
           </a:p>
           <a:p xmlns:a="http://schemas.openxmlformats.org/drawingml/2006/main">
             <a:pPr algn="l">
+              <a:buNone/>
               <a:defRPr sz="1725" b="0">
                 <a:solidFill>
                   <a:srgbClr val="F5FAFF"/>
@@ -5107,6 +5032,7 @@
           </a:p>
           <a:p xmlns:a="http://schemas.openxmlformats.org/drawingml/2006/main">
             <a:pPr algn="l">
+              <a:buNone/>
               <a:defRPr sz="1725" b="0">
                 <a:solidFill>
                   <a:srgbClr val="F5FAFF"/>
@@ -5124,6 +5050,7 @@
           </a:p>
           <a:p xmlns:a="http://schemas.openxmlformats.org/drawingml/2006/main">
             <a:pPr algn="l">
+              <a:buNone/>
               <a:defRPr sz="1725" b="0">
                 <a:solidFill>
                   <a:srgbClr val="F5FAFF"/>
@@ -5141,6 +5068,7 @@
           </a:p>
           <a:p xmlns:a="http://schemas.openxmlformats.org/drawingml/2006/main">
             <a:pPr algn="l">
+              <a:buNone/>
               <a:defRPr sz="1725" b="0">
                 <a:solidFill>
                   <a:srgbClr val="F5FAFF"/>
@@ -5199,14 +5127,14 @@
       </p:sp>
       <p:pic>
         <p:nvPicPr>
-          <p:cNvPr id="17" name=""/>
+          <p:cNvPr id="19" name=""/>
           <p:cNvPicPr>
             <a:picLocks xmlns:a="http://schemas.openxmlformats.org/drawingml/2006/main" noChangeAspect="1"/>
           </p:cNvPicPr>
           <p:nvPr/>
         </p:nvPicPr>
         <p:blipFill>
-          <a:blip xmlns:r="http://schemas.openxmlformats.org/officeDocument/2006/relationships" xmlns:a="http://schemas.openxmlformats.org/drawingml/2006/main" r:embed="Ra585d255b85a4f47"/>
+          <a:blip xmlns:r="http://schemas.openxmlformats.org/officeDocument/2006/relationships" xmlns:a="http://schemas.openxmlformats.org/drawingml/2006/main" r:embed="R5f305c5bff5d4533"/>
           <a:srcRect xmlns:a="http://schemas.openxmlformats.org/drawingml/2006/main" l="0" t="1892" r="0" b="1892"/>
           <a:stretch xmlns:a="http://schemas.openxmlformats.org/drawingml/2006/main">
             <a:fillRect l="0" t="0" r="0" b="0"/>
@@ -5288,6 +5216,7 @@
           <a:lstStyle xmlns:a="http://schemas.openxmlformats.org/drawingml/2006/main"/>
           <a:p xmlns:a="http://schemas.openxmlformats.org/drawingml/2006/main">
             <a:pPr algn="l">
+              <a:buNone/>
               <a:defRPr sz="1050" b="1">
                 <a:solidFill>
                   <a:srgbClr val="A9C6DC"/>
@@ -5338,6 +5267,7 @@
           <a:lstStyle xmlns:a="http://schemas.openxmlformats.org/drawingml/2006/main"/>
           <a:p xmlns:a="http://schemas.openxmlformats.org/drawingml/2006/main">
             <a:pPr algn="r">
+              <a:buNone/>
               <a:defRPr sz="1050" b="1">
                 <a:solidFill>
                   <a:srgbClr val="A9C6DC"/>
@@ -5448,6 +5378,7 @@
           <a:lstStyle xmlns:a="http://schemas.openxmlformats.org/drawingml/2006/main"/>
           <a:p xmlns:a="http://schemas.openxmlformats.org/drawingml/2006/main">
             <a:pPr algn="l">
+              <a:buNone/>
               <a:defRPr sz="1575" b="1">
                 <a:solidFill>
                   <a:srgbClr val="FF6A3D"/>
@@ -5460,7 +5391,7 @@
                   <a:srgbClr val="FF6A3D"/>
                 </a:solidFill>
               </a:rPr>
-              <a:t>SKY OLİMPİYATLARI</a:t>
+              <a:t>SKY OLİMPİYATLARI  /  2026 III. DÖNEM</a:t>
             </a:r>
           </a:p>
         </p:txBody>
@@ -5498,6 +5429,7 @@
           <a:lstStyle xmlns:a="http://schemas.openxmlformats.org/drawingml/2006/main"/>
           <a:p xmlns:a="http://schemas.openxmlformats.org/drawingml/2006/main">
             <a:pPr algn="l">
+              <a:buNone/>
               <a:defRPr sz="4650" b="1">
                 <a:solidFill>
                   <a:srgbClr val="F5FAFF"/>
@@ -5515,6 +5447,7 @@
           </a:p>
           <a:p xmlns:a="http://schemas.openxmlformats.org/drawingml/2006/main">
             <a:pPr algn="l">
+              <a:buNone/>
               <a:defRPr sz="4650" b="1">
                 <a:solidFill>
                   <a:srgbClr val="F5FAFF"/>
@@ -5527,7 +5460,7 @@
                   <a:srgbClr val="F5FAFF"/>
                 </a:solidFill>
               </a:rPr>
-              <a:t>oynatılabilen bir şey yaptım.</a:t>
+              <a:t>oynatılabilen bir proje.</a:t>
             </a:r>
           </a:p>
         </p:txBody>
@@ -5565,6 +5498,7 @@
           <a:lstStyle xmlns:a="http://schemas.openxmlformats.org/drawingml/2006/main"/>
           <a:p xmlns:a="http://schemas.openxmlformats.org/drawingml/2006/main">
             <a:pPr algn="l">
+              <a:buNone/>
               <a:defRPr sz="2250" b="0">
                 <a:solidFill>
                   <a:srgbClr val="36C2FF"/>
@@ -5577,7 +5511,7 @@
                   <a:srgbClr val="36C2FF"/>
                 </a:solidFill>
               </a:rPr>
-              <a:t>Küçük kaldı. Tamamlandı. Oynanıyor.</a:t>
+              <a:t>Küçük, tamamlanmış ve doğrudan oynanabilir.</a:t>
             </a:r>
           </a:p>
         </p:txBody>
@@ -5615,6 +5549,7 @@
           <a:lstStyle xmlns:a="http://schemas.openxmlformats.org/drawingml/2006/main"/>
           <a:p xmlns:a="http://schemas.openxmlformats.org/drawingml/2006/main">
             <a:pPr algn="l">
+              <a:buNone/>
               <a:defRPr sz="1950" b="0">
                 <a:solidFill>
                   <a:srgbClr val="F5FAFF"/>
@@ -5627,7 +5562,25 @@
                   <a:srgbClr val="F5FAFF"/>
                 </a:solidFill>
               </a:rPr>
-              <a:t>Benim için sonuçtan daha önemli olan şey, ilk fikre bağlı kalıp geri bildirimle defalarca düzeltmekti.</a:t>
+              <a:t>Oyunun çalıştığı volitanlabs.dev sitesini de ben geliştirdim.</a:t>
+            </a:r>
+          </a:p>
+          <a:p xmlns:a="http://schemas.openxmlformats.org/drawingml/2006/main">
+            <a:pPr algn="l">
+              <a:buNone/>
+              <a:defRPr sz="1950" b="0">
+                <a:solidFill>
+                  <a:srgbClr val="F5FAFF"/>
+                </a:solidFill>
+              </a:defRPr>
+            </a:pPr>
+            <a:r>
+              <a:rPr sz="1950" b="0">
+                <a:solidFill>
+                  <a:srgbClr val="F5FAFF"/>
+                </a:solidFill>
+              </a:rPr>
+              <a:t>Sunumdan sonra açıp oynayabilirsiniz.</a:t>
             </a:r>
           </a:p>
         </p:txBody>
@@ -5665,6 +5618,7 @@
           <a:lstStyle xmlns:a="http://schemas.openxmlformats.org/drawingml/2006/main"/>
           <a:p xmlns:a="http://schemas.openxmlformats.org/drawingml/2006/main">
             <a:pPr algn="l">
+              <a:buNone/>
               <a:defRPr sz="1800" b="1">
                 <a:solidFill>
                   <a:srgbClr val="D6F55F"/>
@@ -5723,17 +5677,17 @@
       </p:sp>
       <p:pic>
         <p:nvPicPr>
-          <p:cNvPr id="20" name=""/>
+          <p:cNvPr id="22" name=""/>
           <p:cNvPicPr>
             <a:picLocks xmlns:a="http://schemas.openxmlformats.org/drawingml/2006/main" noChangeAspect="1"/>
           </p:cNvPicPr>
           <p:nvPr/>
         </p:nvPicPr>
         <p:blipFill>
-          <a:blip xmlns:r="http://schemas.openxmlformats.org/officeDocument/2006/relationships" xmlns:a="http://schemas.openxmlformats.org/drawingml/2006/main" r:embed="Rea4129a8def648bb">
+          <a:blip xmlns:r="http://schemas.openxmlformats.org/officeDocument/2006/relationships" xmlns:a="http://schemas.openxmlformats.org/drawingml/2006/main" r:embed="R41474fad8a7544a6">
             <a:extLst>
               <a:ext uri="{96DAC541-7B7A-43D3-8B79-37D633B846F1}">
-                <asvg:svgBlip xmlns:asvg="http://schemas.microsoft.com/office/drawing/2016/SVG/main" r:embed="Rb0d22bf8588d4138"/>
+                <asvg:svgBlip xmlns:asvg="http://schemas.microsoft.com/office/drawing/2016/SVG/main" r:embed="R676bb460cef84d3e"/>
               </a:ext>
             </a:extLst>
           </a:blip>
@@ -5782,6 +5736,7 @@
           <a:lstStyle xmlns:a="http://schemas.openxmlformats.org/drawingml/2006/main"/>
           <a:p xmlns:a="http://schemas.openxmlformats.org/drawingml/2006/main">
             <a:pPr algn="ctr">
+              <a:buNone/>
               <a:defRPr sz="1875" b="1">
                 <a:solidFill>
                   <a:srgbClr val="03172D"/>
@@ -5863,6 +5818,7 @@
           <a:lstStyle xmlns:a="http://schemas.openxmlformats.org/drawingml/2006/main"/>
           <a:p xmlns:a="http://schemas.openxmlformats.org/drawingml/2006/main">
             <a:pPr algn="l">
+              <a:buNone/>
               <a:defRPr sz="1050" b="1">
                 <a:solidFill>
                   <a:srgbClr val="A9C6DC"/>
@@ -5913,6 +5869,7 @@
           <a:lstStyle xmlns:a="http://schemas.openxmlformats.org/drawingml/2006/main"/>
           <a:p xmlns:a="http://schemas.openxmlformats.org/drawingml/2006/main">
             <a:pPr algn="r">
+              <a:buNone/>
               <a:defRPr sz="1050" b="1">
                 <a:solidFill>
                   <a:srgbClr val="A9C6DC"/>

</xml_diff>

<commit_message>
Embed QR image in SKY presentation
</commit_message>
<xml_diff>
--- a/public/presentations/Blue_Rescue_SKY_Olimpiyatlari_Sunumu.pptx
+++ b/public/presentations/Blue_Rescue_SKY_Olimpiyatlari_Sunumu.pptx
@@ -2,19 +2,19 @@
 <file path=ppt/presentation.xml><?xml version="1.0" encoding="utf-8"?>
 <p:presentation xmlns:p="http://schemas.openxmlformats.org/presentationml/2006/main">
   <p:sldMasterIdLst>
-    <p:sldMasterId xmlns:r="http://schemas.openxmlformats.org/officeDocument/2006/relationships" id="2147483648" r:id="R7e97a7ba80474af5"/>
+    <p:sldMasterId xmlns:r="http://schemas.openxmlformats.org/officeDocument/2006/relationships" id="2147483648" r:id="R93452fbd4dbb4a25"/>
   </p:sldMasterIdLst>
   <p:notesMasterIdLst>
-    <p:notesMasterId xmlns:r="http://schemas.openxmlformats.org/officeDocument/2006/relationships" r:id="R4971e5f5eb2e49d5"/>
+    <p:notesMasterId xmlns:r="http://schemas.openxmlformats.org/officeDocument/2006/relationships" r:id="Re66b2b56aa974f22"/>
   </p:notesMasterIdLst>
   <p:sldIdLst>
-    <p:sldId xmlns:r="http://schemas.openxmlformats.org/officeDocument/2006/relationships" id="256" r:id="R5fbe878f4fc5448d"/>
-    <p:sldId xmlns:r="http://schemas.openxmlformats.org/officeDocument/2006/relationships" id="257" r:id="Rf45362f78b174807"/>
-    <p:sldId xmlns:r="http://schemas.openxmlformats.org/officeDocument/2006/relationships" id="258" r:id="R6818673fe5d54ff7"/>
-    <p:sldId xmlns:r="http://schemas.openxmlformats.org/officeDocument/2006/relationships" id="259" r:id="Rc1dec57feb674946"/>
-    <p:sldId xmlns:r="http://schemas.openxmlformats.org/officeDocument/2006/relationships" id="260" r:id="R2755b233417f471a"/>
-    <p:sldId xmlns:r="http://schemas.openxmlformats.org/officeDocument/2006/relationships" id="261" r:id="Re9edd172c70044b5"/>
-    <p:sldId xmlns:r="http://schemas.openxmlformats.org/officeDocument/2006/relationships" id="262" r:id="R31104ebeac00438c"/>
+    <p:sldId xmlns:r="http://schemas.openxmlformats.org/officeDocument/2006/relationships" id="256" r:id="R76281a7526214569"/>
+    <p:sldId xmlns:r="http://schemas.openxmlformats.org/officeDocument/2006/relationships" id="257" r:id="Rd505cfd0c12f4c70"/>
+    <p:sldId xmlns:r="http://schemas.openxmlformats.org/officeDocument/2006/relationships" id="258" r:id="R29050f280c9a4603"/>
+    <p:sldId xmlns:r="http://schemas.openxmlformats.org/officeDocument/2006/relationships" id="259" r:id="Rbe3cb04d80fc407d"/>
+    <p:sldId xmlns:r="http://schemas.openxmlformats.org/officeDocument/2006/relationships" id="260" r:id="Reb04e6e0253f44e7"/>
+    <p:sldId xmlns:r="http://schemas.openxmlformats.org/officeDocument/2006/relationships" id="261" r:id="R8510595850a842b4"/>
+    <p:sldId xmlns:r="http://schemas.openxmlformats.org/officeDocument/2006/relationships" id="262" r:id="R3ba735fd935d4c26"/>
   </p:sldIdLst>
   <p:sldSz cx="12192000" cy="6858000"/>
   <p:notesSz cx="6858000" cy="9144000"/>
@@ -938,7 +938,7 @@
           </a:p>
           <a:p xmlns:a="http://schemas.openxmlformats.org/drawingml/2006/main">
             <a:r>
-              <a:t>QR kodu: D:/tusasgame/_site/public/images/games/blue-rescue/qr-volitanlabs.svg</a:t>
+              <a:t>QR kodu: D:/tusasgame/.presentation-revision-20260903/qr-fixed/qr-volitanlabs-hires.png</a:t>
             </a:r>
           </a:p>
         </p:txBody>
@@ -1006,7 +1006,7 @@
   </p:cSld>
   <p:clrMap bg1="lt1" tx1="dk1" bg2="lt2" tx2="dk2" accent1="accent1" accent2="accent2" accent3="accent3" accent4="accent4" accent5="accent5" accent6="accent6" hlink="hlink" folHlink="folHlink"/>
   <p:sldLayoutIdLst>
-    <p:sldLayoutId xmlns:r="http://schemas.openxmlformats.org/officeDocument/2006/relationships" id="2147483649" r:id="R19142873795a490d"/>
+    <p:sldLayoutId xmlns:r="http://schemas.openxmlformats.org/officeDocument/2006/relationships" id="2147483649" r:id="R269247e941dd4907"/>
   </p:sldLayoutIdLst>
   <p:txStyles>
     <p:titleStyle>
@@ -1955,7 +1955,7 @@
           <p:nvPr/>
         </p:nvPicPr>
         <p:blipFill>
-          <a:blip xmlns:r="http://schemas.openxmlformats.org/officeDocument/2006/relationships" xmlns:a="http://schemas.openxmlformats.org/drawingml/2006/main" r:embed="R1d706dca39394384"/>
+          <a:blip xmlns:r="http://schemas.openxmlformats.org/officeDocument/2006/relationships" xmlns:a="http://schemas.openxmlformats.org/drawingml/2006/main" r:embed="R0a2636e88a0e440e"/>
           <a:srcRect xmlns:a="http://schemas.openxmlformats.org/drawingml/2006/main" l="0" t="4" r="0" b="4"/>
           <a:stretch xmlns:a="http://schemas.openxmlformats.org/drawingml/2006/main">
             <a:fillRect l="0" t="0" r="0" b="0"/>
@@ -3045,7 +3045,7 @@
           <p:nvPr/>
         </p:nvPicPr>
         <p:blipFill>
-          <a:blip xmlns:r="http://schemas.openxmlformats.org/officeDocument/2006/relationships" xmlns:a="http://schemas.openxmlformats.org/drawingml/2006/main" r:embed="R3a2f5de30268446f"/>
+          <a:blip xmlns:r="http://schemas.openxmlformats.org/officeDocument/2006/relationships" xmlns:a="http://schemas.openxmlformats.org/drawingml/2006/main" r:embed="R1ea7bf65ea99460e"/>
           <a:srcRect xmlns:a="http://schemas.openxmlformats.org/drawingml/2006/main" l="0" t="1734" r="0" b="1734"/>
           <a:stretch xmlns:a="http://schemas.openxmlformats.org/drawingml/2006/main">
             <a:fillRect l="0" t="0" r="0" b="0"/>
@@ -3444,7 +3444,7 @@
           <p:nvPr/>
         </p:nvPicPr>
         <p:blipFill>
-          <a:blip xmlns:r="http://schemas.openxmlformats.org/officeDocument/2006/relationships" xmlns:a="http://schemas.openxmlformats.org/drawingml/2006/main" r:embed="Rcdbfc7cd3eda480c"/>
+          <a:blip xmlns:r="http://schemas.openxmlformats.org/officeDocument/2006/relationships" xmlns:a="http://schemas.openxmlformats.org/drawingml/2006/main" r:embed="Rc118d352a0a84aec"/>
           <a:stretch xmlns:a="http://schemas.openxmlformats.org/drawingml/2006/main"/>
         </p:blipFill>
         <p:spPr>
@@ -3609,7 +3609,7 @@
           <p:nvPr/>
         </p:nvPicPr>
         <p:blipFill>
-          <a:blip xmlns:r="http://schemas.openxmlformats.org/officeDocument/2006/relationships" xmlns:a="http://schemas.openxmlformats.org/drawingml/2006/main" r:embed="Ra0509fe0ff6d45f6"/>
+          <a:blip xmlns:r="http://schemas.openxmlformats.org/officeDocument/2006/relationships" xmlns:a="http://schemas.openxmlformats.org/drawingml/2006/main" r:embed="Rb26f2d76a9c7445a"/>
           <a:stretch xmlns:a="http://schemas.openxmlformats.org/drawingml/2006/main"/>
         </p:blipFill>
         <p:spPr>
@@ -4143,7 +4143,7 @@
           <p:nvPr/>
         </p:nvPicPr>
         <p:blipFill>
-          <a:blip xmlns:r="http://schemas.openxmlformats.org/officeDocument/2006/relationships" xmlns:a="http://schemas.openxmlformats.org/drawingml/2006/main" r:embed="R5aa2e01b03124649"/>
+          <a:blip xmlns:r="http://schemas.openxmlformats.org/officeDocument/2006/relationships" xmlns:a="http://schemas.openxmlformats.org/drawingml/2006/main" r:embed="R8d9e49515ac74f0f"/>
           <a:srcRect xmlns:a="http://schemas.openxmlformats.org/drawingml/2006/main" l="0" t="18308" r="0" b="18308"/>
           <a:stretch xmlns:a="http://schemas.openxmlformats.org/drawingml/2006/main">
             <a:fillRect l="0" t="0" r="0" b="0"/>
@@ -4311,7 +4311,7 @@
           <p:nvPr/>
         </p:nvPicPr>
         <p:blipFill>
-          <a:blip xmlns:r="http://schemas.openxmlformats.org/officeDocument/2006/relationships" xmlns:a="http://schemas.openxmlformats.org/drawingml/2006/main" r:embed="Rd4897cc56392456e"/>
+          <a:blip xmlns:r="http://schemas.openxmlformats.org/officeDocument/2006/relationships" xmlns:a="http://schemas.openxmlformats.org/drawingml/2006/main" r:embed="R38ecf1be985146bc"/>
           <a:srcRect xmlns:a="http://schemas.openxmlformats.org/drawingml/2006/main" l="0" t="18308" r="0" b="18308"/>
           <a:stretch xmlns:a="http://schemas.openxmlformats.org/drawingml/2006/main">
             <a:fillRect l="0" t="0" r="0" b="0"/>
@@ -4479,7 +4479,7 @@
           <p:nvPr/>
         </p:nvPicPr>
         <p:blipFill>
-          <a:blip xmlns:r="http://schemas.openxmlformats.org/officeDocument/2006/relationships" xmlns:a="http://schemas.openxmlformats.org/drawingml/2006/main" r:embed="R21fbed5aab834d41"/>
+          <a:blip xmlns:r="http://schemas.openxmlformats.org/officeDocument/2006/relationships" xmlns:a="http://schemas.openxmlformats.org/drawingml/2006/main" r:embed="R44570681eac24fbe"/>
           <a:srcRect xmlns:a="http://schemas.openxmlformats.org/drawingml/2006/main" l="0" t="18308" r="0" b="18308"/>
           <a:stretch xmlns:a="http://schemas.openxmlformats.org/drawingml/2006/main">
             <a:fillRect l="0" t="0" r="0" b="0"/>
@@ -5134,7 +5134,7 @@
           <p:nvPr/>
         </p:nvPicPr>
         <p:blipFill>
-          <a:blip xmlns:r="http://schemas.openxmlformats.org/officeDocument/2006/relationships" xmlns:a="http://schemas.openxmlformats.org/drawingml/2006/main" r:embed="R5f305c5bff5d4533"/>
+          <a:blip xmlns:r="http://schemas.openxmlformats.org/officeDocument/2006/relationships" xmlns:a="http://schemas.openxmlformats.org/drawingml/2006/main" r:embed="R0f4982bdfcc14824"/>
           <a:srcRect xmlns:a="http://schemas.openxmlformats.org/drawingml/2006/main" l="0" t="1892" r="0" b="1892"/>
           <a:stretch xmlns:a="http://schemas.openxmlformats.org/drawingml/2006/main">
             <a:fillRect l="0" t="0" r="0" b="0"/>
@@ -5684,13 +5684,7 @@
           <p:nvPr/>
         </p:nvPicPr>
         <p:blipFill>
-          <a:blip xmlns:r="http://schemas.openxmlformats.org/officeDocument/2006/relationships" xmlns:a="http://schemas.openxmlformats.org/drawingml/2006/main" r:embed="R41474fad8a7544a6">
-            <a:extLst>
-              <a:ext uri="{96DAC541-7B7A-43D3-8B79-37D633B846F1}">
-                <asvg:svgBlip xmlns:asvg="http://schemas.microsoft.com/office/drawing/2016/SVG/main" r:embed="R676bb460cef84d3e"/>
-              </a:ext>
-            </a:extLst>
-          </a:blip>
+          <a:blip xmlns:r="http://schemas.openxmlformats.org/officeDocument/2006/relationships" xmlns:a="http://schemas.openxmlformats.org/drawingml/2006/main" r:embed="R89d965cec91c4483"/>
           <a:stretch xmlns:a="http://schemas.openxmlformats.org/drawingml/2006/main"/>
         </p:blipFill>
         <p:spPr>

</xml_diff>

<commit_message>
Update Blue Rescue presentation narrative
</commit_message>
<xml_diff>
--- a/public/presentations/Blue_Rescue_SKY_Olimpiyatlari_Sunumu.pptx
+++ b/public/presentations/Blue_Rescue_SKY_Olimpiyatlari_Sunumu.pptx
@@ -2,19 +2,20 @@
 <file path=ppt/presentation.xml><?xml version="1.0" encoding="utf-8"?>
 <p:presentation xmlns:p="http://schemas.openxmlformats.org/presentationml/2006/main">
   <p:sldMasterIdLst>
-    <p:sldMasterId xmlns:r="http://schemas.openxmlformats.org/officeDocument/2006/relationships" id="2147483648" r:id="R93452fbd4dbb4a25"/>
+    <p:sldMasterId xmlns:r="http://schemas.openxmlformats.org/officeDocument/2006/relationships" id="2147483648" r:id="Ref73d9cf07a34dbb"/>
   </p:sldMasterIdLst>
   <p:notesMasterIdLst>
-    <p:notesMasterId xmlns:r="http://schemas.openxmlformats.org/officeDocument/2006/relationships" r:id="Re66b2b56aa974f22"/>
+    <p:notesMasterId xmlns:r="http://schemas.openxmlformats.org/officeDocument/2006/relationships" r:id="R52493d7aa41f4d69"/>
   </p:notesMasterIdLst>
   <p:sldIdLst>
-    <p:sldId xmlns:r="http://schemas.openxmlformats.org/officeDocument/2006/relationships" id="256" r:id="R76281a7526214569"/>
-    <p:sldId xmlns:r="http://schemas.openxmlformats.org/officeDocument/2006/relationships" id="257" r:id="Rd505cfd0c12f4c70"/>
-    <p:sldId xmlns:r="http://schemas.openxmlformats.org/officeDocument/2006/relationships" id="258" r:id="R29050f280c9a4603"/>
-    <p:sldId xmlns:r="http://schemas.openxmlformats.org/officeDocument/2006/relationships" id="259" r:id="Rbe3cb04d80fc407d"/>
-    <p:sldId xmlns:r="http://schemas.openxmlformats.org/officeDocument/2006/relationships" id="260" r:id="Reb04e6e0253f44e7"/>
-    <p:sldId xmlns:r="http://schemas.openxmlformats.org/officeDocument/2006/relationships" id="261" r:id="R8510595850a842b4"/>
-    <p:sldId xmlns:r="http://schemas.openxmlformats.org/officeDocument/2006/relationships" id="262" r:id="R3ba735fd935d4c26"/>
+    <p:sldId xmlns:r="http://schemas.openxmlformats.org/officeDocument/2006/relationships" id="256" r:id="Rad574bd1c6304cc4"/>
+    <p:sldId xmlns:r="http://schemas.openxmlformats.org/officeDocument/2006/relationships" id="257" r:id="R4faf395efc2b4cc6"/>
+    <p:sldId xmlns:r="http://schemas.openxmlformats.org/officeDocument/2006/relationships" id="258" r:id="Ree95e3cb610a41b0"/>
+    <p:sldId xmlns:r="http://schemas.openxmlformats.org/officeDocument/2006/relationships" id="259" r:id="Rf157e294e13a4fde"/>
+    <p:sldId xmlns:r="http://schemas.openxmlformats.org/officeDocument/2006/relationships" id="260" r:id="R78c666581a974797"/>
+    <p:sldId xmlns:r="http://schemas.openxmlformats.org/officeDocument/2006/relationships" id="261" r:id="R101700302faf4a48"/>
+    <p:sldId xmlns:r="http://schemas.openxmlformats.org/officeDocument/2006/relationships" id="262" r:id="Rab4516b4cbd044e2"/>
+    <p:sldId xmlns:r="http://schemas.openxmlformats.org/officeDocument/2006/relationships" id="263" r:id="R382446c8eb01450a"/>
   </p:sldIdLst>
   <p:sldSz cx="12192000" cy="6858000"/>
   <p:notesSz cx="6858000" cy="9144000"/>
@@ -453,7 +454,7 @@
           </a:p>
           <a:p xmlns:a="http://schemas.openxmlformats.org/drawingml/2006/main">
             <a:r>
-              <a:t>Proje ve staj bağlamı: kullanıcı tarafından sağlanan bilgiler.</a:t>
+              <a:t>SKY Olimpiyatları, dönem ve proje bağlamı: kullanıcı tarafından sağlanan bilgiler.</a:t>
             </a:r>
           </a:p>
           <a:p xmlns:a="http://schemas.openxmlformats.org/drawingml/2006/main">
@@ -538,7 +539,12 @@
           </a:p>
           <a:p xmlns:a="http://schemas.openxmlformats.org/drawingml/2006/main">
             <a:r>
-              <a:t>Yetkinlik eşlemesi: Yaratıcılık ve İnovasyon; destekleyici olarak Problem Çözme ve Dijital Okuryazarlık.</a:t>
+              <a:t>GÖKBEY resmî ürün bilgisi: https://www.tusas.com/urunler/helikopter/ozgun-gelistirme/gokbey</a:t>
+            </a:r>
+          </a:p>
+          <a:p xmlns:a="http://schemas.openxmlformats.org/drawingml/2006/main">
+            <a:r>
+              <a:t>Kişisel motivasyon ve hedef kitle: kullanıcı tarafından sağlanan bilgiler.</a:t>
             </a:r>
           </a:p>
         </p:txBody>
@@ -613,7 +619,7 @@
           </a:p>
           <a:p xmlns:a="http://schemas.openxmlformats.org/drawingml/2006/main">
             <a:r>
-              <a:t>GÖKBEY stajı ve prototip projesi deneyimi: kullanıcı tarafından sağlanan kişisel bilgiler.</a:t>
+              <a:t>GÖKBEY stajı, prototip projesi deneyimi ve izin sınırı: kullanıcı tarafından sağlanan bilgiler.</a:t>
             </a:r>
           </a:p>
           <a:p xmlns:a="http://schemas.openxmlformats.org/drawingml/2006/main">
@@ -889,6 +895,81 @@
 </file>
 
 <file path=ppt/notesSlides/notesSlide7.xml><?xml version="1.0" encoding="utf-8"?>
+<p:notes xmlns:p="http://schemas.openxmlformats.org/presentationml/2006/main">
+  <p:cSld>
+    <p:spTree>
+      <p:nvGrpSpPr>
+        <p:cNvPr id="1" name=""/>
+        <p:cNvGrpSpPr/>
+        <p:nvPr/>
+      </p:nvGrpSpPr>
+      <p:grpSpPr>
+        <a:xfrm xmlns:a="http://schemas.openxmlformats.org/drawingml/2006/main"/>
+      </p:grpSpPr>
+      <p:sp>
+        <p:nvSpPr>
+          <p:cNvPr id="2" name="Slide Image Placeholder 1"/>
+          <p:cNvSpPr>
+            <a:spLocks xmlns:a="http://schemas.openxmlformats.org/drawingml/2006/main" noGrp="1"/>
+          </p:cNvSpPr>
+          <p:nvPr>
+            <p:ph type="sldImg" idx="0"/>
+          </p:nvPr>
+        </p:nvSpPr>
+        <p:spPr/>
+      </p:sp>
+      <p:sp>
+        <p:nvSpPr>
+          <p:cNvPr id="3" name="Notes Placeholder 2"/>
+          <p:cNvSpPr>
+            <a:spLocks xmlns:a="http://schemas.openxmlformats.org/drawingml/2006/main" noGrp="1"/>
+          </p:cNvSpPr>
+          <p:nvPr>
+            <p:ph type="body" idx="1"/>
+          </p:nvPr>
+        </p:nvSpPr>
+        <p:spPr/>
+        <p:txBody>
+          <a:bodyPr xmlns:a="http://schemas.openxmlformats.org/drawingml/2006/main"/>
+          <a:lstStyle xmlns:a="http://schemas.openxmlformats.org/drawingml/2006/main"/>
+          <a:p xmlns:a="http://schemas.openxmlformats.org/drawingml/2006/main">
+            <a:r>
+              <a:t>[Sources]</a:t>
+            </a:r>
+          </a:p>
+          <a:p xmlns:a="http://schemas.openxmlformats.org/drawingml/2006/main">
+            <a:r>
+              <a:t>Gelecek çalışma başlıkları ve izin sınırı: kullanıcı ile mentöründen gelen geri bildirim.</a:t>
+            </a:r>
+          </a:p>
+        </p:txBody>
+      </p:sp>
+      <p:sp>
+        <p:nvSpPr>
+          <p:cNvPr id="4" name="Slide Number Placeholder 3"/>
+          <p:cNvSpPr>
+            <a:spLocks xmlns:a="http://schemas.openxmlformats.org/drawingml/2006/main" noGrp="1"/>
+          </p:cNvSpPr>
+          <p:nvPr>
+            <p:ph type="sldNum" idx="5"/>
+          </p:nvPr>
+        </p:nvSpPr>
+        <p:spPr/>
+        <p:txBody>
+          <a:bodyPr xmlns:a="http://schemas.openxmlformats.org/drawingml/2006/main"/>
+          <a:lstStyle xmlns:a="http://schemas.openxmlformats.org/drawingml/2006/main"/>
+          <a:p xmlns:a="http://schemas.openxmlformats.org/drawingml/2006/main"/>
+        </p:txBody>
+      </p:sp>
+    </p:spTree>
+  </p:cSld>
+  <p:clrMapOvr>
+    <a:masterClrMapping xmlns:a="http://schemas.openxmlformats.org/drawingml/2006/main"/>
+  </p:clrMapOvr>
+</p:notes>
+</file>
+
+<file path=ppt/notesSlides/notesSlide8.xml><?xml version="1.0" encoding="utf-8"?>
 <p:notes xmlns:p="http://schemas.openxmlformats.org/presentationml/2006/main">
   <p:cSld>
     <p:spTree>
@@ -1006,7 +1087,7 @@
   </p:cSld>
   <p:clrMap bg1="lt1" tx1="dk1" bg2="lt2" tx2="dk2" accent1="accent1" accent2="accent2" accent3="accent3" accent4="accent4" accent5="accent5" accent6="accent6" hlink="hlink" folHlink="folHlink"/>
   <p:sldLayoutIdLst>
-    <p:sldLayoutId xmlns:r="http://schemas.openxmlformats.org/officeDocument/2006/relationships" id="2147483649" r:id="R269247e941dd4907"/>
+    <p:sldLayoutId xmlns:r="http://schemas.openxmlformats.org/officeDocument/2006/relationships" id="2147483649" r:id="Rf822ede3c2174753"/>
   </p:sldLayoutIdLst>
   <p:txStyles>
     <p:titleStyle>
@@ -1782,7 +1863,7 @@
                   <a:srgbClr val="F5FAFF"/>
                 </a:solidFill>
               </a:rPr>
-              <a:t>Beklenen bir staj sunumu yerine,</a:t>
+              <a:t>SKY Olimpiyatları için geliştirilmiş</a:t>
             </a:r>
           </a:p>
           <a:p xmlns:a="http://schemas.openxmlformats.org/drawingml/2006/main">
@@ -1800,7 +1881,7 @@
                   <a:srgbClr val="F5FAFF"/>
                 </a:solidFill>
               </a:rPr>
-              <a:t>oynanabilir küçük bir proje.</a:t>
+              <a:t>oynanabilir bir kurtarma projesi.</a:t>
             </a:r>
           </a:p>
         </p:txBody>
@@ -1955,7 +2036,7 @@
           <p:nvPr/>
         </p:nvPicPr>
         <p:blipFill>
-          <a:blip xmlns:r="http://schemas.openxmlformats.org/officeDocument/2006/relationships" xmlns:a="http://schemas.openxmlformats.org/drawingml/2006/main" r:embed="R0a2636e88a0e440e"/>
+          <a:blip xmlns:r="http://schemas.openxmlformats.org/officeDocument/2006/relationships" xmlns:a="http://schemas.openxmlformats.org/drawingml/2006/main" r:embed="Rc6822c334a714a6e"/>
           <a:srcRect xmlns:a="http://schemas.openxmlformats.org/drawingml/2006/main" l="0" t="4" r="0" b="4"/>
           <a:stretch xmlns:a="http://schemas.openxmlformats.org/drawingml/2006/main">
             <a:fillRect l="0" t="0" r="0" b="0"/>
@@ -2250,7 +2331,7 @@
                   <a:srgbClr val="F5FAFF"/>
                 </a:solidFill>
               </a:rPr>
-              <a:t>Yetkinliği anlatmak yerine,</a:t>
+              <a:t>Fikri çalışan, oynanabilir</a:t>
             </a:r>
           </a:p>
           <a:p xmlns:a="http://schemas.openxmlformats.org/drawingml/2006/main">
@@ -2268,7 +2349,7 @@
                   <a:srgbClr val="F5FAFF"/>
                 </a:solidFill>
               </a:rPr>
-              <a:t>çalışan bir projeyle gösteriyorum.</a:t>
+              <a:t>bir projeye dönüştürüyorum.</a:t>
             </a:r>
           </a:p>
         </p:txBody>
@@ -2401,7 +2482,7 @@
                   <a:srgbClr val="F5FAFF"/>
                 </a:solidFill>
               </a:rPr>
-              <a:t>Küçük bir</a:t>
+              <a:t>Kişisel bağdan</a:t>
             </a:r>
           </a:p>
           <a:p xmlns:a="http://schemas.openxmlformats.org/drawingml/2006/main">
@@ -2419,7 +2500,7 @@
                   <a:srgbClr val="F5FAFF"/>
                 </a:solidFill>
               </a:rPr>
-              <a:t>kurtarma oyunu</a:t>
+              <a:t>paylaşılabilir deneyime</a:t>
             </a:r>
           </a:p>
         </p:txBody>
@@ -2470,25 +2551,7 @@
                   <a:srgbClr val="A9C6DC"/>
                 </a:solidFill>
               </a:rPr>
-              <a:t>Isıl analiz odaklı bir staj sunumu beklenebilir.</a:t>
-            </a:r>
-          </a:p>
-          <a:p xmlns:a="http://schemas.openxmlformats.org/drawingml/2006/main">
-            <a:pPr algn="l">
-              <a:buNone/>
-              <a:defRPr sz="2025" b="0">
-                <a:solidFill>
-                  <a:srgbClr val="A9C6DC"/>
-                </a:solidFill>
-              </a:defRPr>
-            </a:pPr>
-            <a:r>
-              <a:rPr sz="2025" b="0">
-                <a:solidFill>
-                  <a:srgbClr val="A9C6DC"/>
-                </a:solidFill>
-              </a:rPr>
-              <a:t>Ben daha etkileşimli ve akılda kalan bir format seçiyorum.</a:t>
+              <a:t>GÖKBEY tarafındaki geçmişim temaya kişisel bir bağ kuruyor. Yerli imkânlarla geliştirilen ilk genel maksat helikopterini, gençlere etkileşimli bir formatla anlatıyorum.</a:t>
             </a:r>
           </a:p>
         </p:txBody>
@@ -2539,7 +2602,7 @@
                   <a:srgbClr val="36C2FF"/>
                 </a:solidFill>
               </a:rPr>
-              <a:t>Destekleyen beceriler: Problem çözme · Dijital okuryazarlık</a:t>
+              <a:t>Amaç: merak uyandırmak · tanınırlığa katkı sağlamak</a:t>
             </a:r>
           </a:p>
         </p:txBody>
@@ -2854,7 +2917,7 @@
                   <a:srgbClr val="36C2FF"/>
                 </a:solidFill>
               </a:rPr>
-              <a:t>Çünkü GÖKBEY</a:t>
+              <a:t>Teması GÖKBEY'den,</a:t>
             </a:r>
           </a:p>
           <a:p xmlns:a="http://schemas.openxmlformats.org/drawingml/2006/main">
@@ -2872,7 +2935,7 @@
                   <a:srgbClr val="36C2FF"/>
                 </a:solidFill>
               </a:rPr>
-              <a:t>tarafındayım.</a:t>
+              <a:t>helikopteri özgün.</a:t>
             </a:r>
           </a:p>
         </p:txBody>
@@ -2992,7 +3055,7 @@
                   <a:srgbClr val="FF6A3D"/>
                 </a:solidFill>
               </a:rPr>
-              <a:t>Helikopter teması buradan geliyor; araç yine de genel ve mavi.</a:t>
+              <a:t>GÖKBEY'i doğrudan oyuna taşımak için kurumsal izin gerekir. Oyundaki araç GÖKBEY değildir; genel ve özgün bir mavi helikopterdir.</a:t>
             </a:r>
           </a:p>
         </p:txBody>
@@ -3045,7 +3108,7 @@
           <p:nvPr/>
         </p:nvPicPr>
         <p:blipFill>
-          <a:blip xmlns:r="http://schemas.openxmlformats.org/officeDocument/2006/relationships" xmlns:a="http://schemas.openxmlformats.org/drawingml/2006/main" r:embed="R1ea7bf65ea99460e"/>
+          <a:blip xmlns:r="http://schemas.openxmlformats.org/officeDocument/2006/relationships" xmlns:a="http://schemas.openxmlformats.org/drawingml/2006/main" r:embed="R71ce3457dc9a4ad1"/>
           <a:srcRect xmlns:a="http://schemas.openxmlformats.org/drawingml/2006/main" l="0" t="1734" r="0" b="1734"/>
           <a:stretch xmlns:a="http://schemas.openxmlformats.org/drawingml/2006/main">
             <a:fillRect l="0" t="0" r="0" b="0"/>
@@ -3444,7 +3507,7 @@
           <p:nvPr/>
         </p:nvPicPr>
         <p:blipFill>
-          <a:blip xmlns:r="http://schemas.openxmlformats.org/officeDocument/2006/relationships" xmlns:a="http://schemas.openxmlformats.org/drawingml/2006/main" r:embed="Rc118d352a0a84aec"/>
+          <a:blip xmlns:r="http://schemas.openxmlformats.org/officeDocument/2006/relationships" xmlns:a="http://schemas.openxmlformats.org/drawingml/2006/main" r:embed="Rfbe1730085ea470c"/>
           <a:stretch xmlns:a="http://schemas.openxmlformats.org/drawingml/2006/main"/>
         </p:blipFill>
         <p:spPr>
@@ -3609,7 +3672,7 @@
           <p:nvPr/>
         </p:nvPicPr>
         <p:blipFill>
-          <a:blip xmlns:r="http://schemas.openxmlformats.org/officeDocument/2006/relationships" xmlns:a="http://schemas.openxmlformats.org/drawingml/2006/main" r:embed="Rb26f2d76a9c7445a"/>
+          <a:blip xmlns:r="http://schemas.openxmlformats.org/officeDocument/2006/relationships" xmlns:a="http://schemas.openxmlformats.org/drawingml/2006/main" r:embed="Rb47874fc40894df4"/>
           <a:stretch xmlns:a="http://schemas.openxmlformats.org/drawingml/2006/main"/>
         </p:blipFill>
         <p:spPr>
@@ -4143,7 +4206,7 @@
           <p:nvPr/>
         </p:nvPicPr>
         <p:blipFill>
-          <a:blip xmlns:r="http://schemas.openxmlformats.org/officeDocument/2006/relationships" xmlns:a="http://schemas.openxmlformats.org/drawingml/2006/main" r:embed="R8d9e49515ac74f0f"/>
+          <a:blip xmlns:r="http://schemas.openxmlformats.org/officeDocument/2006/relationships" xmlns:a="http://schemas.openxmlformats.org/drawingml/2006/main" r:embed="Rcab43bd560494d3a"/>
           <a:srcRect xmlns:a="http://schemas.openxmlformats.org/drawingml/2006/main" l="0" t="18308" r="0" b="18308"/>
           <a:stretch xmlns:a="http://schemas.openxmlformats.org/drawingml/2006/main">
             <a:fillRect l="0" t="0" r="0" b="0"/>
@@ -4311,7 +4374,7 @@
           <p:nvPr/>
         </p:nvPicPr>
         <p:blipFill>
-          <a:blip xmlns:r="http://schemas.openxmlformats.org/officeDocument/2006/relationships" xmlns:a="http://schemas.openxmlformats.org/drawingml/2006/main" r:embed="R38ecf1be985146bc"/>
+          <a:blip xmlns:r="http://schemas.openxmlformats.org/officeDocument/2006/relationships" xmlns:a="http://schemas.openxmlformats.org/drawingml/2006/main" r:embed="R60296adf627348aa"/>
           <a:srcRect xmlns:a="http://schemas.openxmlformats.org/drawingml/2006/main" l="0" t="18308" r="0" b="18308"/>
           <a:stretch xmlns:a="http://schemas.openxmlformats.org/drawingml/2006/main">
             <a:fillRect l="0" t="0" r="0" b="0"/>
@@ -4479,7 +4542,7 @@
           <p:nvPr/>
         </p:nvPicPr>
         <p:blipFill>
-          <a:blip xmlns:r="http://schemas.openxmlformats.org/officeDocument/2006/relationships" xmlns:a="http://schemas.openxmlformats.org/drawingml/2006/main" r:embed="R44570681eac24fbe"/>
+          <a:blip xmlns:r="http://schemas.openxmlformats.org/officeDocument/2006/relationships" xmlns:a="http://schemas.openxmlformats.org/drawingml/2006/main" r:embed="Rc8ea3a83fe17495a"/>
           <a:srcRect xmlns:a="http://schemas.openxmlformats.org/drawingml/2006/main" l="0" t="18308" r="0" b="18308"/>
           <a:stretch xmlns:a="http://schemas.openxmlformats.org/drawingml/2006/main">
             <a:fillRect l="0" t="0" r="0" b="0"/>
@@ -5134,7 +5197,7 @@
           <p:nvPr/>
         </p:nvPicPr>
         <p:blipFill>
-          <a:blip xmlns:r="http://schemas.openxmlformats.org/officeDocument/2006/relationships" xmlns:a="http://schemas.openxmlformats.org/drawingml/2006/main" r:embed="R0f4982bdfcc14824"/>
+          <a:blip xmlns:r="http://schemas.openxmlformats.org/officeDocument/2006/relationships" xmlns:a="http://schemas.openxmlformats.org/drawingml/2006/main" r:embed="R22626143b4ac4c55"/>
           <a:srcRect xmlns:a="http://schemas.openxmlformats.org/drawingml/2006/main" l="0" t="1892" r="0" b="1892"/>
           <a:stretch xmlns:a="http://schemas.openxmlformats.org/drawingml/2006/main">
             <a:fillRect l="0" t="0" r="0" b="0"/>
@@ -5296,6 +5359,674 @@
 </file>
 
 <file path=ppt/slides/slide7.xml><?xml version="1.0" encoding="utf-8"?>
+<p:sld xmlns:p="http://schemas.openxmlformats.org/presentationml/2006/main">
+  <p:cSld>
+    <p:bg>
+      <p:bgPr>
+        <a:solidFill xmlns:a="http://schemas.openxmlformats.org/drawingml/2006/main">
+          <a:srgbClr val="03172D"/>
+        </a:solidFill>
+      </p:bgPr>
+    </p:bg>
+    <p:spTree>
+      <p:nvGrpSpPr>
+        <p:cNvPr id="1" name=""/>
+        <p:cNvGrpSpPr/>
+        <p:nvPr/>
+      </p:nvGrpSpPr>
+      <p:grpSpPr>
+        <a:xfrm xmlns:a="http://schemas.openxmlformats.org/drawingml/2006/main"/>
+      </p:grpSpPr>
+      <p:sp>
+        <p:nvSpPr>
+          <p:cNvPr id="14" name="eyebrow">
+            <a:extLst xmlns:a="http://schemas.openxmlformats.org/drawingml/2006/main">
+              <a:ext uri="{FF2B5EF4-FFF2-40B4-BE49-F238E27FC236}">
+                <a16:creationId xmlns:a16="http://schemas.microsoft.com/office/drawing/2014/main" id="{EC297B24-62BD-4950-9E5D-8FC2E4A27E35}"/>
+              </a:ext>
+            </a:extLst>
+          </p:cNvPr>
+          <p:cNvSpPr>
+            <a:spLocks xmlns:a="http://schemas.openxmlformats.org/drawingml/2006/main" noGrp="1"/>
+          </p:cNvSpPr>
+          <p:nvPr/>
+        </p:nvSpPr>
+        <p:spPr>
+          <a:xfrm xmlns:a="http://schemas.openxmlformats.org/drawingml/2006/main">
+            <a:off x="685800" y="400050"/>
+            <a:ext cx="6667500" cy="266700"/>
+          </a:xfrm>
+          <a:prstGeom xmlns:a="http://schemas.openxmlformats.org/drawingml/2006/main" prst="rect">
+            <a:avLst/>
+          </a:prstGeom>
+          <a:noFill xmlns:a="http://schemas.openxmlformats.org/drawingml/2006/main"/>
+          <a:ln xmlns:a="http://schemas.openxmlformats.org/drawingml/2006/main" w="0">
+            <a:noFill/>
+            <a:prstDash val="solid"/>
+          </a:ln>
+        </p:spPr>
+        <p:txBody>
+          <a:bodyPr xmlns:a="http://schemas.openxmlformats.org/drawingml/2006/main" anchor="t"/>
+          <a:lstStyle xmlns:a="http://schemas.openxmlformats.org/drawingml/2006/main"/>
+          <a:p xmlns:a="http://schemas.openxmlformats.org/drawingml/2006/main">
+            <a:pPr algn="l">
+              <a:buNone/>
+              <a:defRPr sz="1350" b="1">
+                <a:solidFill>
+                  <a:srgbClr val="36C2FF"/>
+                </a:solidFill>
+              </a:defRPr>
+            </a:pPr>
+            <a:r>
+              <a:rPr sz="1350" b="1">
+                <a:solidFill>
+                  <a:srgbClr val="36C2FF"/>
+                </a:solidFill>
+              </a:rPr>
+              <a:t>GELECEK ÇALIŞMALAR</a:t>
+            </a:r>
+          </a:p>
+        </p:txBody>
+      </p:sp>
+      <p:sp>
+        <p:nvSpPr>
+          <p:cNvPr id="2" name="choice-title">
+            <a:extLst xmlns:a="http://schemas.openxmlformats.org/drawingml/2006/main">
+              <a:ext uri="{FF2B5EF4-FFF2-40B4-BE49-F238E27FC236}">
+                <a16:creationId xmlns:a16="http://schemas.microsoft.com/office/drawing/2014/main" id="{137FC675-76FC-4F2A-9999-6802A6A4D92B}"/>
+              </a:ext>
+            </a:extLst>
+          </p:cNvPr>
+          <p:cNvSpPr>
+            <a:spLocks xmlns:a="http://schemas.openxmlformats.org/drawingml/2006/main" noGrp="1"/>
+          </p:cNvSpPr>
+          <p:nvPr/>
+        </p:nvSpPr>
+        <p:spPr>
+          <a:xfrm xmlns:a="http://schemas.openxmlformats.org/drawingml/2006/main">
+            <a:off x="685800" y="895350"/>
+            <a:ext cx="5143500" cy="704850"/>
+          </a:xfrm>
+          <a:prstGeom xmlns:a="http://schemas.openxmlformats.org/drawingml/2006/main" prst="rect">
+            <a:avLst/>
+          </a:prstGeom>
+          <a:noFill xmlns:a="http://schemas.openxmlformats.org/drawingml/2006/main"/>
+          <a:ln xmlns:a="http://schemas.openxmlformats.org/drawingml/2006/main" w="0">
+            <a:noFill/>
+            <a:prstDash val="solid"/>
+          </a:ln>
+        </p:spPr>
+        <p:txBody>
+          <a:bodyPr xmlns:a="http://schemas.openxmlformats.org/drawingml/2006/main" anchor="t"/>
+          <a:lstStyle xmlns:a="http://schemas.openxmlformats.org/drawingml/2006/main"/>
+          <a:p xmlns:a="http://schemas.openxmlformats.org/drawingml/2006/main">
+            <a:pPr algn="l">
+              <a:buNone/>
+              <a:defRPr sz="4050" b="1">
+                <a:solidFill>
+                  <a:srgbClr val="F5FAFF"/>
+                </a:solidFill>
+              </a:defRPr>
+            </a:pPr>
+            <a:r>
+              <a:rPr sz="4050" b="1">
+                <a:solidFill>
+                  <a:srgbClr val="F5FAFF"/>
+                </a:solidFill>
+              </a:rPr>
+              <a:t>Görev çeşitliliği</a:t>
+            </a:r>
+          </a:p>
+        </p:txBody>
+      </p:sp>
+      <p:sp>
+        <p:nvSpPr>
+          <p:cNvPr id="3" name="choice-expected">
+            <a:extLst xmlns:a="http://schemas.openxmlformats.org/drawingml/2006/main">
+              <a:ext uri="{FF2B5EF4-FFF2-40B4-BE49-F238E27FC236}">
+                <a16:creationId xmlns:a16="http://schemas.microsoft.com/office/drawing/2014/main" id="{8CE5F8E7-0A80-4187-8106-1A4DD7E93DD5}"/>
+              </a:ext>
+            </a:extLst>
+          </p:cNvPr>
+          <p:cNvSpPr>
+            <a:spLocks xmlns:a="http://schemas.openxmlformats.org/drawingml/2006/main" noGrp="1"/>
+          </p:cNvSpPr>
+          <p:nvPr/>
+        </p:nvSpPr>
+        <p:spPr>
+          <a:xfrm xmlns:a="http://schemas.openxmlformats.org/drawingml/2006/main">
+            <a:off x="742950" y="2152650"/>
+            <a:ext cx="4857750" cy="1200150"/>
+          </a:xfrm>
+          <a:prstGeom xmlns:a="http://schemas.openxmlformats.org/drawingml/2006/main" prst="rect">
+            <a:avLst/>
+          </a:prstGeom>
+          <a:noFill xmlns:a="http://schemas.openxmlformats.org/drawingml/2006/main"/>
+          <a:ln xmlns:a="http://schemas.openxmlformats.org/drawingml/2006/main" w="0">
+            <a:noFill/>
+            <a:prstDash val="solid"/>
+          </a:ln>
+        </p:spPr>
+        <p:txBody>
+          <a:bodyPr xmlns:a="http://schemas.openxmlformats.org/drawingml/2006/main" anchor="t"/>
+          <a:lstStyle xmlns:a="http://schemas.openxmlformats.org/drawingml/2006/main"/>
+          <a:p xmlns:a="http://schemas.openxmlformats.org/drawingml/2006/main">
+            <a:pPr algn="l">
+              <a:buNone/>
+              <a:defRPr sz="2850" b="1">
+                <a:solidFill>
+                  <a:srgbClr val="A9C6DC"/>
+                </a:solidFill>
+              </a:defRPr>
+            </a:pPr>
+            <a:r>
+              <a:rPr sz="2850" b="1">
+                <a:solidFill>
+                  <a:srgbClr val="A9C6DC"/>
+                </a:solidFill>
+              </a:rPr>
+              <a:t>Yangın söndürme</a:t>
+            </a:r>
+          </a:p>
+          <a:p xmlns:a="http://schemas.openxmlformats.org/drawingml/2006/main">
+            <a:pPr algn="l">
+              <a:buNone/>
+              <a:defRPr sz="2850" b="1">
+                <a:solidFill>
+                  <a:srgbClr val="A9C6DC"/>
+                </a:solidFill>
+              </a:defRPr>
+            </a:pPr>
+            <a:r>
+              <a:rPr sz="2850" b="1">
+                <a:solidFill>
+                  <a:srgbClr val="A9C6DC"/>
+                </a:solidFill>
+              </a:rPr>
+              <a:t>ve tahliye</a:t>
+            </a:r>
+          </a:p>
+        </p:txBody>
+      </p:sp>
+      <p:sp>
+        <p:nvSpPr>
+          <p:cNvPr id="4" name="choice-divider">
+            <a:extLst xmlns:a="http://schemas.openxmlformats.org/drawingml/2006/main">
+              <a:ext uri="{FF2B5EF4-FFF2-40B4-BE49-F238E27FC236}">
+                <a16:creationId xmlns:a16="http://schemas.microsoft.com/office/drawing/2014/main" id="{5219590F-6AD4-4F7B-8CC4-C79B30D6DFC0}"/>
+              </a:ext>
+            </a:extLst>
+          </p:cNvPr>
+          <p:cNvSpPr>
+            <a:spLocks xmlns:a="http://schemas.openxmlformats.org/drawingml/2006/main" noGrp="1"/>
+          </p:cNvSpPr>
+          <p:nvPr/>
+        </p:nvSpPr>
+        <p:spPr>
+          <a:xfrm xmlns:a="http://schemas.openxmlformats.org/drawingml/2006/main">
+            <a:off x="742950" y="3638550"/>
+            <a:ext cx="4381500" cy="28575"/>
+          </a:xfrm>
+          <a:prstGeom xmlns:a="http://schemas.openxmlformats.org/drawingml/2006/main" prst="rect">
+            <a:avLst/>
+          </a:prstGeom>
+          <a:solidFill xmlns:a="http://schemas.openxmlformats.org/drawingml/2006/main">
+            <a:srgbClr val="1D5279"/>
+          </a:solidFill>
+          <a:ln xmlns:a="http://schemas.openxmlformats.org/drawingml/2006/main" w="0">
+            <a:noFill/>
+            <a:prstDash val="solid"/>
+          </a:ln>
+        </p:spPr>
+      </p:sp>
+      <p:sp>
+        <p:nvSpPr>
+          <p:cNvPr id="5" name="choice-turn">
+            <a:extLst xmlns:a="http://schemas.openxmlformats.org/drawingml/2006/main">
+              <a:ext uri="{FF2B5EF4-FFF2-40B4-BE49-F238E27FC236}">
+                <a16:creationId xmlns:a16="http://schemas.microsoft.com/office/drawing/2014/main" id="{1F4DDB37-79E1-4B49-982A-0CA5699371FB}"/>
+              </a:ext>
+            </a:extLst>
+          </p:cNvPr>
+          <p:cNvSpPr>
+            <a:spLocks xmlns:a="http://schemas.openxmlformats.org/drawingml/2006/main" noGrp="1"/>
+          </p:cNvSpPr>
+          <p:nvPr/>
+        </p:nvSpPr>
+        <p:spPr>
+          <a:xfrm xmlns:a="http://schemas.openxmlformats.org/drawingml/2006/main">
+            <a:off x="742950" y="3943350"/>
+            <a:ext cx="4953000" cy="952500"/>
+          </a:xfrm>
+          <a:prstGeom xmlns:a="http://schemas.openxmlformats.org/drawingml/2006/main" prst="rect">
+            <a:avLst/>
+          </a:prstGeom>
+          <a:noFill xmlns:a="http://schemas.openxmlformats.org/drawingml/2006/main"/>
+          <a:ln xmlns:a="http://schemas.openxmlformats.org/drawingml/2006/main" w="0">
+            <a:noFill/>
+            <a:prstDash val="solid"/>
+          </a:ln>
+        </p:spPr>
+        <p:txBody>
+          <a:bodyPr xmlns:a="http://schemas.openxmlformats.org/drawingml/2006/main" anchor="t"/>
+          <a:lstStyle xmlns:a="http://schemas.openxmlformats.org/drawingml/2006/main"/>
+          <a:p xmlns:a="http://schemas.openxmlformats.org/drawingml/2006/main">
+            <a:pPr algn="l">
+              <a:buNone/>
+              <a:defRPr sz="1950" b="0">
+                <a:solidFill>
+                  <a:srgbClr val="F5FAFF"/>
+                </a:solidFill>
+              </a:defRPr>
+            </a:pPr>
+            <a:r>
+              <a:rPr sz="1950" b="0">
+                <a:solidFill>
+                  <a:srgbClr val="F5FAFF"/>
+                </a:solidFill>
+              </a:rPr>
+              <a:t>Aynı uçuş mekaniği, farklı kurtarma hedefleriyle genişletilebilir.</a:t>
+            </a:r>
+          </a:p>
+        </p:txBody>
+      </p:sp>
+      <p:sp>
+        <p:nvSpPr>
+          <p:cNvPr id="6" name="choice-right-bg">
+            <a:extLst xmlns:a="http://schemas.openxmlformats.org/drawingml/2006/main">
+              <a:ext uri="{FF2B5EF4-FFF2-40B4-BE49-F238E27FC236}">
+                <a16:creationId xmlns:a16="http://schemas.microsoft.com/office/drawing/2014/main" id="{7A4FFD0D-AFB0-4C81-8B60-B503CC65BDF1}"/>
+              </a:ext>
+            </a:extLst>
+          </p:cNvPr>
+          <p:cNvSpPr>
+            <a:spLocks xmlns:a="http://schemas.openxmlformats.org/drawingml/2006/main" noGrp="1"/>
+          </p:cNvSpPr>
+          <p:nvPr/>
+        </p:nvSpPr>
+        <p:spPr>
+          <a:xfrm xmlns:a="http://schemas.openxmlformats.org/drawingml/2006/main">
+            <a:off x="6191250" y="0"/>
+            <a:ext cx="6000750" cy="6858000"/>
+          </a:xfrm>
+          <a:prstGeom xmlns:a="http://schemas.openxmlformats.org/drawingml/2006/main" prst="rect">
+            <a:avLst/>
+          </a:prstGeom>
+          <a:solidFill xmlns:a="http://schemas.openxmlformats.org/drawingml/2006/main">
+            <a:srgbClr val="062441"/>
+          </a:solidFill>
+          <a:ln xmlns:a="http://schemas.openxmlformats.org/drawingml/2006/main" w="0">
+            <a:noFill/>
+            <a:prstDash val="solid"/>
+          </a:ln>
+        </p:spPr>
+      </p:sp>
+      <p:sp>
+        <p:nvSpPr>
+          <p:cNvPr id="7" name="choice-right-kicker">
+            <a:extLst xmlns:a="http://schemas.openxmlformats.org/drawingml/2006/main">
+              <a:ext uri="{FF2B5EF4-FFF2-40B4-BE49-F238E27FC236}">
+                <a16:creationId xmlns:a16="http://schemas.microsoft.com/office/drawing/2014/main" id="{DEAF550D-F181-4E52-A732-4E426F2B2BBF}"/>
+              </a:ext>
+            </a:extLst>
+          </p:cNvPr>
+          <p:cNvSpPr>
+            <a:spLocks xmlns:a="http://schemas.openxmlformats.org/drawingml/2006/main" noGrp="1"/>
+          </p:cNvSpPr>
+          <p:nvPr/>
+        </p:nvSpPr>
+        <p:spPr>
+          <a:xfrm xmlns:a="http://schemas.openxmlformats.org/drawingml/2006/main">
+            <a:off x="6781800" y="1104900"/>
+            <a:ext cx="4476750" cy="285750"/>
+          </a:xfrm>
+          <a:prstGeom xmlns:a="http://schemas.openxmlformats.org/drawingml/2006/main" prst="rect">
+            <a:avLst/>
+          </a:prstGeom>
+          <a:noFill xmlns:a="http://schemas.openxmlformats.org/drawingml/2006/main"/>
+          <a:ln xmlns:a="http://schemas.openxmlformats.org/drawingml/2006/main" w="0">
+            <a:noFill/>
+            <a:prstDash val="solid"/>
+          </a:ln>
+        </p:spPr>
+        <p:txBody>
+          <a:bodyPr xmlns:a="http://schemas.openxmlformats.org/drawingml/2006/main" anchor="t"/>
+          <a:lstStyle xmlns:a="http://schemas.openxmlformats.org/drawingml/2006/main"/>
+          <a:p xmlns:a="http://schemas.openxmlformats.org/drawingml/2006/main">
+            <a:pPr algn="l">
+              <a:buNone/>
+              <a:defRPr sz="1500" b="1">
+                <a:solidFill>
+                  <a:srgbClr val="FF6A3D"/>
+                </a:solidFill>
+              </a:defRPr>
+            </a:pPr>
+            <a:r>
+              <a:rPr sz="1500" b="1">
+                <a:solidFill>
+                  <a:srgbClr val="FF6A3D"/>
+                </a:solidFill>
+              </a:rPr>
+              <a:t>FARKLI ARAÇLAR</a:t>
+            </a:r>
+          </a:p>
+        </p:txBody>
+      </p:sp>
+      <p:sp>
+        <p:nvSpPr>
+          <p:cNvPr id="8" name="choice-right-title">
+            <a:extLst xmlns:a="http://schemas.openxmlformats.org/drawingml/2006/main">
+              <a:ext uri="{FF2B5EF4-FFF2-40B4-BE49-F238E27FC236}">
+                <a16:creationId xmlns:a16="http://schemas.microsoft.com/office/drawing/2014/main" id="{0EA6A3C8-FF63-436D-9550-D76F5C35E11E}"/>
+              </a:ext>
+            </a:extLst>
+          </p:cNvPr>
+          <p:cNvSpPr>
+            <a:spLocks xmlns:a="http://schemas.openxmlformats.org/drawingml/2006/main" noGrp="1"/>
+          </p:cNvSpPr>
+          <p:nvPr/>
+        </p:nvSpPr>
+        <p:spPr>
+          <a:xfrm xmlns:a="http://schemas.openxmlformats.org/drawingml/2006/main">
+            <a:off x="6781800" y="1676400"/>
+            <a:ext cx="4762500" cy="1447800"/>
+          </a:xfrm>
+          <a:prstGeom xmlns:a="http://schemas.openxmlformats.org/drawingml/2006/main" prst="rect">
+            <a:avLst/>
+          </a:prstGeom>
+          <a:noFill xmlns:a="http://schemas.openxmlformats.org/drawingml/2006/main"/>
+          <a:ln xmlns:a="http://schemas.openxmlformats.org/drawingml/2006/main" w="0">
+            <a:noFill/>
+            <a:prstDash val="solid"/>
+          </a:ln>
+        </p:spPr>
+        <p:txBody>
+          <a:bodyPr xmlns:a="http://schemas.openxmlformats.org/drawingml/2006/main" anchor="t"/>
+          <a:lstStyle xmlns:a="http://schemas.openxmlformats.org/drawingml/2006/main"/>
+          <a:p xmlns:a="http://schemas.openxmlformats.org/drawingml/2006/main">
+            <a:pPr algn="l">
+              <a:buNone/>
+              <a:defRPr sz="4350" b="1">
+                <a:solidFill>
+                  <a:srgbClr val="F5FAFF"/>
+                </a:solidFill>
+              </a:defRPr>
+            </a:pPr>
+            <a:r>
+              <a:rPr sz="4350" b="1">
+                <a:solidFill>
+                  <a:srgbClr val="F5FAFF"/>
+                </a:solidFill>
+              </a:rPr>
+              <a:t>Yeni helikopter</a:t>
+            </a:r>
+          </a:p>
+          <a:p xmlns:a="http://schemas.openxmlformats.org/drawingml/2006/main">
+            <a:pPr algn="l">
+              <a:buNone/>
+              <a:defRPr sz="4350" b="1">
+                <a:solidFill>
+                  <a:srgbClr val="F5FAFF"/>
+                </a:solidFill>
+              </a:defRPr>
+            </a:pPr>
+            <a:r>
+              <a:rPr sz="4350" b="1">
+                <a:solidFill>
+                  <a:srgbClr val="F5FAFF"/>
+                </a:solidFill>
+              </a:rPr>
+              <a:t>sınıfları</a:t>
+            </a:r>
+          </a:p>
+        </p:txBody>
+      </p:sp>
+      <p:sp>
+        <p:nvSpPr>
+          <p:cNvPr id="9" name="choice-right-body">
+            <a:extLst xmlns:a="http://schemas.openxmlformats.org/drawingml/2006/main">
+              <a:ext uri="{FF2B5EF4-FFF2-40B4-BE49-F238E27FC236}">
+                <a16:creationId xmlns:a16="http://schemas.microsoft.com/office/drawing/2014/main" id="{9525DD3A-C08C-4180-83C3-64803BBB3EF2}"/>
+              </a:ext>
+            </a:extLst>
+          </p:cNvPr>
+          <p:cNvSpPr>
+            <a:spLocks xmlns:a="http://schemas.openxmlformats.org/drawingml/2006/main" noGrp="1"/>
+          </p:cNvSpPr>
+          <p:nvPr/>
+        </p:nvSpPr>
+        <p:spPr>
+          <a:xfrm xmlns:a="http://schemas.openxmlformats.org/drawingml/2006/main">
+            <a:off x="6781800" y="3619500"/>
+            <a:ext cx="4476750" cy="1257300"/>
+          </a:xfrm>
+          <a:prstGeom xmlns:a="http://schemas.openxmlformats.org/drawingml/2006/main" prst="rect">
+            <a:avLst/>
+          </a:prstGeom>
+          <a:noFill xmlns:a="http://schemas.openxmlformats.org/drawingml/2006/main"/>
+          <a:ln xmlns:a="http://schemas.openxmlformats.org/drawingml/2006/main" w="0">
+            <a:noFill/>
+            <a:prstDash val="solid"/>
+          </a:ln>
+        </p:spPr>
+        <p:txBody>
+          <a:bodyPr xmlns:a="http://schemas.openxmlformats.org/drawingml/2006/main" anchor="t"/>
+          <a:lstStyle xmlns:a="http://schemas.openxmlformats.org/drawingml/2006/main"/>
+          <a:p xmlns:a="http://schemas.openxmlformats.org/drawingml/2006/main">
+            <a:pPr algn="l">
+              <a:buNone/>
+              <a:defRPr sz="2025" b="0">
+                <a:solidFill>
+                  <a:srgbClr val="A9C6DC"/>
+                </a:solidFill>
+              </a:defRPr>
+            </a:pPr>
+            <a:r>
+              <a:rPr sz="2025" b="0">
+                <a:solidFill>
+                  <a:srgbClr val="A9C6DC"/>
+                </a:solidFill>
+              </a:rPr>
+              <a:t>Genel maksat, hava ambulansı veya taarruz helikopteri temaları; her biri farklı görev ritmi ve engel yapısı sunabilir.</a:t>
+            </a:r>
+          </a:p>
+        </p:txBody>
+      </p:sp>
+      <p:sp>
+        <p:nvSpPr>
+          <p:cNvPr id="10" name="choice-right-close">
+            <a:extLst xmlns:a="http://schemas.openxmlformats.org/drawingml/2006/main">
+              <a:ext uri="{FF2B5EF4-FFF2-40B4-BE49-F238E27FC236}">
+                <a16:creationId xmlns:a16="http://schemas.microsoft.com/office/drawing/2014/main" id="{95785DCC-4E9D-4746-8819-AB1FC32CE85A}"/>
+              </a:ext>
+            </a:extLst>
+          </p:cNvPr>
+          <p:cNvSpPr>
+            <a:spLocks xmlns:a="http://schemas.openxmlformats.org/drawingml/2006/main" noGrp="1"/>
+          </p:cNvSpPr>
+          <p:nvPr/>
+        </p:nvSpPr>
+        <p:spPr>
+          <a:xfrm xmlns:a="http://schemas.openxmlformats.org/drawingml/2006/main">
+            <a:off x="6781800" y="5391150"/>
+            <a:ext cx="4476750" cy="571500"/>
+          </a:xfrm>
+          <a:prstGeom xmlns:a="http://schemas.openxmlformats.org/drawingml/2006/main" prst="rect">
+            <a:avLst/>
+          </a:prstGeom>
+          <a:noFill xmlns:a="http://schemas.openxmlformats.org/drawingml/2006/main"/>
+          <a:ln xmlns:a="http://schemas.openxmlformats.org/drawingml/2006/main" w="0">
+            <a:noFill/>
+            <a:prstDash val="solid"/>
+          </a:ln>
+        </p:spPr>
+        <p:txBody>
+          <a:bodyPr xmlns:a="http://schemas.openxmlformats.org/drawingml/2006/main" anchor="t"/>
+          <a:lstStyle xmlns:a="http://schemas.openxmlformats.org/drawingml/2006/main"/>
+          <a:p xmlns:a="http://schemas.openxmlformats.org/drawingml/2006/main">
+            <a:pPr algn="l">
+              <a:buNone/>
+              <a:defRPr sz="1800" b="1">
+                <a:solidFill>
+                  <a:srgbClr val="36C2FF"/>
+                </a:solidFill>
+              </a:defRPr>
+            </a:pPr>
+            <a:r>
+              <a:rPr sz="1800" b="1">
+                <a:solidFill>
+                  <a:srgbClr val="36C2FF"/>
+                </a:solidFill>
+              </a:rPr>
+              <a:t>Marka, platform adı ve resmî görseller yalnızca gerekli izinlerle kullanılır.</a:t>
+            </a:r>
+          </a:p>
+        </p:txBody>
+      </p:sp>
+      <p:sp>
+        <p:nvSpPr>
+          <p:cNvPr id="11" name="footer-line-2">
+            <a:extLst xmlns:a="http://schemas.openxmlformats.org/drawingml/2006/main">
+              <a:ext uri="{FF2B5EF4-FFF2-40B4-BE49-F238E27FC236}">
+                <a16:creationId xmlns:a16="http://schemas.microsoft.com/office/drawing/2014/main" id="{113E29DE-0E29-47FC-BEB6-25B06A089509}"/>
+              </a:ext>
+            </a:extLst>
+          </p:cNvPr>
+          <p:cNvSpPr>
+            <a:spLocks xmlns:a="http://schemas.openxmlformats.org/drawingml/2006/main" noGrp="1"/>
+          </p:cNvSpPr>
+          <p:nvPr/>
+        </p:nvSpPr>
+        <p:spPr>
+          <a:xfrm xmlns:a="http://schemas.openxmlformats.org/drawingml/2006/main">
+            <a:off x="685800" y="6419850"/>
+            <a:ext cx="10820400" cy="19050"/>
+          </a:xfrm>
+          <a:prstGeom xmlns:a="http://schemas.openxmlformats.org/drawingml/2006/main" prst="rect">
+            <a:avLst/>
+          </a:prstGeom>
+          <a:solidFill xmlns:a="http://schemas.openxmlformats.org/drawingml/2006/main">
+            <a:srgbClr val="1D5279"/>
+          </a:solidFill>
+          <a:ln xmlns:a="http://schemas.openxmlformats.org/drawingml/2006/main" w="0">
+            <a:noFill/>
+            <a:prstDash val="solid"/>
+          </a:ln>
+        </p:spPr>
+      </p:sp>
+      <p:sp>
+        <p:nvSpPr>
+          <p:cNvPr id="12" name="footer-name-2">
+            <a:extLst xmlns:a="http://schemas.openxmlformats.org/drawingml/2006/main">
+              <a:ext uri="{FF2B5EF4-FFF2-40B4-BE49-F238E27FC236}">
+                <a16:creationId xmlns:a16="http://schemas.microsoft.com/office/drawing/2014/main" id="{CE7D754E-9C69-4063-85F8-674FA0EA9FFC}"/>
+              </a:ext>
+            </a:extLst>
+          </p:cNvPr>
+          <p:cNvSpPr>
+            <a:spLocks xmlns:a="http://schemas.openxmlformats.org/drawingml/2006/main" noGrp="1"/>
+          </p:cNvSpPr>
+          <p:nvPr/>
+        </p:nvSpPr>
+        <p:spPr>
+          <a:xfrm xmlns:a="http://schemas.openxmlformats.org/drawingml/2006/main">
+            <a:off x="685800" y="6505575"/>
+            <a:ext cx="3429000" cy="209550"/>
+          </a:xfrm>
+          <a:prstGeom xmlns:a="http://schemas.openxmlformats.org/drawingml/2006/main" prst="rect">
+            <a:avLst/>
+          </a:prstGeom>
+          <a:noFill xmlns:a="http://schemas.openxmlformats.org/drawingml/2006/main"/>
+          <a:ln xmlns:a="http://schemas.openxmlformats.org/drawingml/2006/main" w="0">
+            <a:noFill/>
+            <a:prstDash val="solid"/>
+          </a:ln>
+        </p:spPr>
+        <p:txBody>
+          <a:bodyPr xmlns:a="http://schemas.openxmlformats.org/drawingml/2006/main" anchor="t"/>
+          <a:lstStyle xmlns:a="http://schemas.openxmlformats.org/drawingml/2006/main"/>
+          <a:p xmlns:a="http://schemas.openxmlformats.org/drawingml/2006/main">
+            <a:pPr algn="l">
+              <a:buNone/>
+              <a:defRPr sz="1050" b="1">
+                <a:solidFill>
+                  <a:srgbClr val="A9C6DC"/>
+                </a:solidFill>
+              </a:defRPr>
+            </a:pPr>
+            <a:r>
+              <a:rPr sz="1050" b="1">
+                <a:solidFill>
+                  <a:srgbClr val="A9C6DC"/>
+                </a:solidFill>
+              </a:rPr>
+              <a:t>MUHAMMED EREN GÖKCEOĞLU</a:t>
+            </a:r>
+          </a:p>
+        </p:txBody>
+      </p:sp>
+      <p:sp>
+        <p:nvSpPr>
+          <p:cNvPr id="13" name="footer-page-2">
+            <a:extLst xmlns:a="http://schemas.openxmlformats.org/drawingml/2006/main">
+              <a:ext uri="{FF2B5EF4-FFF2-40B4-BE49-F238E27FC236}">
+                <a16:creationId xmlns:a16="http://schemas.microsoft.com/office/drawing/2014/main" id="{33B4A919-7787-4C96-A8B4-4B9811988859}"/>
+              </a:ext>
+            </a:extLst>
+          </p:cNvPr>
+          <p:cNvSpPr>
+            <a:spLocks xmlns:a="http://schemas.openxmlformats.org/drawingml/2006/main" noGrp="1"/>
+          </p:cNvSpPr>
+          <p:nvPr/>
+        </p:nvSpPr>
+        <p:spPr>
+          <a:xfrm xmlns:a="http://schemas.openxmlformats.org/drawingml/2006/main">
+            <a:off x="10858500" y="6505575"/>
+            <a:ext cx="647700" cy="209550"/>
+          </a:xfrm>
+          <a:prstGeom xmlns:a="http://schemas.openxmlformats.org/drawingml/2006/main" prst="rect">
+            <a:avLst/>
+          </a:prstGeom>
+          <a:noFill xmlns:a="http://schemas.openxmlformats.org/drawingml/2006/main"/>
+          <a:ln xmlns:a="http://schemas.openxmlformats.org/drawingml/2006/main" w="0">
+            <a:noFill/>
+            <a:prstDash val="solid"/>
+          </a:ln>
+        </p:spPr>
+        <p:txBody>
+          <a:bodyPr xmlns:a="http://schemas.openxmlformats.org/drawingml/2006/main" anchor="t"/>
+          <a:lstStyle xmlns:a="http://schemas.openxmlformats.org/drawingml/2006/main"/>
+          <a:p xmlns:a="http://schemas.openxmlformats.org/drawingml/2006/main">
+            <a:pPr algn="r">
+              <a:buNone/>
+              <a:defRPr sz="1050" b="1">
+                <a:solidFill>
+                  <a:srgbClr val="A9C6DC"/>
+                </a:solidFill>
+              </a:defRPr>
+            </a:pPr>
+            <a:r>
+              <a:rPr sz="1050" b="1">
+                <a:solidFill>
+                  <a:srgbClr val="A9C6DC"/>
+                </a:solidFill>
+              </a:rPr>
+              <a:t>07</a:t>
+            </a:r>
+          </a:p>
+        </p:txBody>
+      </p:sp>
+    </p:spTree>
+    <p:extLst>
+      <p:ext uri="{BB962C8B-B14F-4D97-AF65-F5344CB8AC3E}">
+        <p14:creationId xmlns:p14="http://schemas.microsoft.com/office/powerpoint/2010/main" val="1139124792"/>
+      </p:ext>
+    </p:extLst>
+  </p:cSld>
+</p:sld>
+</file>
+
+<file path=ppt/slides/slide8.xml><?xml version="1.0" encoding="utf-8"?>
 <p:sld xmlns:p="http://schemas.openxmlformats.org/presentationml/2006/main">
   <p:cSld>
     <p:bg>
@@ -5684,7 +6415,7 @@
           <p:nvPr/>
         </p:nvPicPr>
         <p:blipFill>
-          <a:blip xmlns:r="http://schemas.openxmlformats.org/officeDocument/2006/relationships" xmlns:a="http://schemas.openxmlformats.org/drawingml/2006/main" r:embed="R89d965cec91c4483"/>
+          <a:blip xmlns:r="http://schemas.openxmlformats.org/officeDocument/2006/relationships" xmlns:a="http://schemas.openxmlformats.org/drawingml/2006/main" r:embed="Re55c3decc8fc4681"/>
           <a:stretch xmlns:a="http://schemas.openxmlformats.org/drawingml/2006/main"/>
         </p:blipFill>
         <p:spPr>
@@ -5876,7 +6607,7 @@
                   <a:srgbClr val="A9C6DC"/>
                 </a:solidFill>
               </a:rPr>
-              <a:t>07</a:t>
+              <a:t>08</a:t>
             </a:r>
           </a:p>
         </p:txBody>

</xml_diff>